<commit_message>
Make Agentic Inference takeaways more technical for汇报 PPT
Co-authored-by: Annie <Annie-Summer@users.noreply.github.com>
</commit_message>
<xml_diff>
--- a/yunqi-2026-pai-forum/docs/洞察一页-05-Agentic Inference：从议题看有状态推理全链路优化.pptx
+++ b/yunqi-2026-pai-forum/docs/洞察一页-05-Agentic Inference：从议题看有状态推理全链路优化.pptx
@@ -3322,7 +3322,7 @@
                 <a:latin typeface="Microsoft YaHei"/>
                 <a:ea typeface="Microsoft YaHei"/>
               </a:rPr>
-              <a:t>一句话判断：Agentic 负载把推理从无状态 QPS 问题，改写成「会话连续 + KV 命中 + Token 成本」问题；PAI 以流量调度 / 引擎执行 / 全局缓存三层协同应对，并用智能选模把质量拉到旗舰水位、成本降约 65%。</a:t>
+              <a:t>一句话判断：Agentic 负载将推理优化目标从无状态 QPS，重构为 Session 连续性、KV Cache 命中率与 Token 级成本；PAI 以流量调度 / 引擎执行 / 全局缓存三层协同闭环，叠加智能选模实现质量对齐旗舰、综合成本约 -65%。</a:t>
             </a:r>
           </a:p>
         </p:txBody>
@@ -3403,7 +3403,7 @@
                 <a:latin typeface="Microsoft YaHei"/>
                 <a:ea typeface="Microsoft YaHei"/>
               </a:rPr>
-              <a:t>01  负载重定义</a:t>
+              <a:t>01  负载与度量重构</a:t>
             </a:r>
           </a:p>
         </p:txBody>
@@ -3443,7 +3443,7 @@
                 <a:latin typeface="Microsoft YaHei"/>
                 <a:ea typeface="Microsoft YaHei"/>
               </a:rPr>
-              <a:t>启示：先按有状态负载建模，再谈引擎调优</a:t>
+              <a:t>启示：调度目标函数从 QPS 切换为 Session亲和×KV命中×Token成本</a:t>
             </a:r>
           </a:p>
           <a:p>
@@ -3460,7 +3460,7 @@
                 <a:latin typeface="Microsoft YaHei"/>
                 <a:ea typeface="Microsoft YaHei"/>
               </a:rPr>
-              <a:t>• 长上下文：4K Token 请求 KV 可超 200MB</a:t>
+              <a:t>• 上下文滚到数万 Token；4K 请求 KV 可超 200MB</a:t>
             </a:r>
           </a:p>
           <a:p>
@@ -3477,7 +3477,7 @@
                 <a:latin typeface="Microsoft YaHei"/>
                 <a:ea typeface="Microsoft YaHei"/>
               </a:rPr>
-              <a:t>• 前缀重叠决定 TTFT/吞吐，命中率是一等指标</a:t>
+              <a:t>• 前缀命中率直接决定 TTFT 与有效吞吐，需一等观测</a:t>
             </a:r>
           </a:p>
           <a:p>
@@ -3494,7 +3494,7 @@
                 <a:latin typeface="Microsoft YaHei"/>
                 <a:ea typeface="Microsoft YaHei"/>
               </a:rPr>
-              <a:t>• 流控按 Token 而非 QPS；同会话需实例亲和</a:t>
+              <a:t>• 限流/配额按 TPM/Token，弹性伸缩保持 KV 连续</a:t>
             </a:r>
           </a:p>
         </p:txBody>
@@ -3575,7 +3575,7 @@
                 <a:latin typeface="Microsoft YaHei"/>
                 <a:ea typeface="Microsoft YaHei"/>
               </a:rPr>
-              <a:t>02  三层协同架构</a:t>
+              <a:t>02  Serving 三层闭环</a:t>
             </a:r>
           </a:p>
         </p:txBody>
@@ -3615,7 +3615,7 @@
                 <a:latin typeface="Microsoft YaHei"/>
                 <a:ea typeface="Microsoft YaHei"/>
               </a:rPr>
-              <a:t>启示：路由 + PD/并行感知 + 全局 KV 必须一体交付</a:t>
+              <a:t>启示：控制面路由、执行面 PD/并行、数据面全局 KV 必须同代交付</a:t>
             </a:r>
           </a:p>
           <a:p>
@@ -3632,7 +3632,7 @@
                 <a:latin typeface="Microsoft YaHei"/>
                 <a:ea typeface="Microsoft YaHei"/>
               </a:rPr>
-              <a:t>• 调度：Session/Cache-Aware，亲和优先、均衡兜底</a:t>
+              <a:t>• Session/Cache-Aware 级联：亲和优先，Least-Token 兜底</a:t>
             </a:r>
           </a:p>
           <a:p>
@@ -3649,7 +3649,7 @@
                 <a:latin typeface="Microsoft YaHei"/>
                 <a:ea typeface="Microsoft YaHei"/>
               </a:rPr>
-              <a:t>• 引擎：全形态 PD + TP/EP/DP 感知，兼容 vLLM/SGLang</a:t>
+              <a:t>• 全形态 PD + TP/EP/DP Rank 感知，兼容 vLLM/SGLang</a:t>
             </a:r>
           </a:p>
           <a:p>
@@ -3666,7 +3666,7 @@
                 <a:latin typeface="Microsoft YaHei"/>
                 <a:ea typeface="Microsoft YaHei"/>
               </a:rPr>
-              <a:t>• FlashKV：DRAM+SSD 全局池，缩容/升级不丢缓存</a:t>
+              <a:t>• FlashKV：DRAM/SSD 分层 + RDMA 直通，缩容升级不丢缓存</a:t>
             </a:r>
           </a:p>
         </p:txBody>
@@ -3747,7 +3747,7 @@
                 <a:latin typeface="Microsoft YaHei"/>
                 <a:ea typeface="Microsoft YaHei"/>
               </a:rPr>
-              <a:t>03  成本与安全闭环</a:t>
+              <a:t>03  成本与可信执行</a:t>
             </a:r>
           </a:p>
         </p:txBody>
@@ -3787,7 +3787,7 @@
                 <a:latin typeface="Microsoft YaHei"/>
                 <a:ea typeface="Microsoft YaHei"/>
               </a:rPr>
-              <a:t>启示：用选模降本，用可验证安全替代口头承诺</a:t>
+              <a:t>启示：用难度分流做质量-成本帕累托，用 TEE 远程证明做可验证安全</a:t>
             </a:r>
           </a:p>
           <a:p>
@@ -3804,7 +3804,7 @@
                 <a:latin typeface="Microsoft YaHei"/>
                 <a:ea typeface="Microsoft YaHei"/>
               </a:rPr>
-              <a:t>• 智能选模：质量 82.7% 对齐旗舰，成本指数 100→35.1</a:t>
+              <a:t>• Auto 选模：SWE-bench 82.7%≈L3，成本指数 100→35.1</a:t>
             </a:r>
           </a:p>
           <a:p>
@@ -3821,7 +3821,7 @@
                 <a:latin typeface="Microsoft YaHei"/>
                 <a:ea typeface="Microsoft YaHei"/>
               </a:rPr>
-              <a:t>• 联邦调度：主区域全局决策，库存跨 Region 随取随用</a:t>
+              <a:t>• 跨 Region 联邦：PRIMARY 全局视图，Spot 库存透明接力</a:t>
             </a:r>
           </a:p>
           <a:p>
@@ -3838,7 +3838,7 @@
                 <a:latin typeface="Microsoft YaHei"/>
                 <a:ea typeface="Microsoft YaHei"/>
               </a:rPr>
-              <a:t>• PAI-CC：TEE + 远程证明，模型/Prompt 可验证密态执行</a:t>
+              <a:t>• PAI-CC：本地加密上云 → 远程证明放行 → E2E 密态推理</a:t>
             </a:r>
           </a:p>
         </p:txBody>
@@ -4871,7 +4871,7 @@
                 <a:latin typeface="Microsoft YaHei"/>
                 <a:ea typeface="Microsoft YaHei"/>
               </a:rPr>
-              <a:t>具体启示：把会话亲和与 KV 命中率写入调度 SLO；用三层 Serving 架构替代单点引擎调优；以智能选模做质量-成本帕累托；用全局 KV 与模型分发吃掉弹性税；用 TEE 远程证明把安全从承诺升级为可验证。</a:t>
+              <a:t>技术启示：将 Session 亲和与 KV 命中率写入调度 SLO/告警；以「智能路由 + PD/并行感知引擎 + 全局 KV」替代单点算子优化；用难度分流选模固化质量-成本帕累托；用全局 KV/模型分发消除缩容与切换带来的冷启动税；用 TEE+远程证明将推理安全从承诺式升级为可验证执行。</a:t>
             </a:r>
           </a:p>
         </p:txBody>

</xml_diff>

<commit_message>
Expand Agentic Inference PPT to cover all.md technical points
Rewrite as a 2-page insight deck spanning load features, routing,
scheduling, auto model select, federation, governance, FlashKV,
model distribution, and confidential computing — with technical takeaways.

Co-authored-by: Annie <Annie-Summer@users.noreply.github.com>
</commit_message>
<xml_diff>
--- a/yunqi-2026-pai-forum/docs/洞察一页-05-Agentic Inference：从议题看有状态推理全链路优化.pptx
+++ b/yunqi-2026-pai-forum/docs/洞察一页-05-Agentic Inference：从议题看有状态推理全链路优化.pptx
@@ -6,6 +6,7 @@
   </p:sldMasterIdLst>
   <p:sldIdLst>
     <p:sldId id="256" r:id="rId7"/>
+    <p:sldId id="257" r:id="rId8"/>
   </p:sldIdLst>
   <p:sldSz cx="12191695" cy="6858000" type="screen4x3"/>
   <p:notesSz cx="6858000" cy="9144000"/>
@@ -3140,7 +3141,7 @@
         <p:spPr>
           <a:xfrm>
             <a:off x="0" y="0"/>
-            <a:ext cx="12191695" cy="1170432"/>
+            <a:ext cx="12191695" cy="1097280"/>
           </a:xfrm>
           <a:prstGeom prst="rect">
             <a:avLst/>
@@ -3182,8 +3183,8 @@
         </p:nvSpPr>
         <p:spPr>
           <a:xfrm>
-            <a:off x="320040" y="91440"/>
-            <a:ext cx="11521440" cy="256032"/>
+            <a:off x="320040" y="73152"/>
+            <a:ext cx="11521440" cy="219456"/>
           </a:xfrm>
           <a:prstGeom prst="rect">
             <a:avLst/>
@@ -3205,7 +3206,7 @@
                 <a:latin typeface="Microsoft YaHei"/>
                 <a:ea typeface="Microsoft YaHei"/>
               </a:rPr>
-              <a:t>05 · 李文鹏 · 阿里云 PAI · Agentic Inference</a:t>
+              <a:t>05 · 李文鹏 · 阿里云 PAI｜第 1/2 页</a:t>
             </a:r>
           </a:p>
         </p:txBody>
@@ -3218,8 +3219,8 @@
         </p:nvSpPr>
         <p:spPr>
           <a:xfrm>
-            <a:off x="320040" y="347472"/>
-            <a:ext cx="11521440" cy="713232"/>
+            <a:off x="320040" y="310896"/>
+            <a:ext cx="11521440" cy="658368"/>
           </a:xfrm>
           <a:prstGeom prst="rect">
             <a:avLst/>
@@ -3234,7 +3235,7 @@
           <a:p>
             <a:pPr algn="l"/>
             <a:r>
-              <a:rPr sz="1700" b="1">
+              <a:rPr sz="1600" b="1">
                 <a:solidFill>
                   <a:srgbClr val="1A1A1A"/>
                 </a:solidFill>
@@ -3254,8 +3255,8 @@
         </p:nvSpPr>
         <p:spPr>
           <a:xfrm>
-            <a:off x="274320" y="1261872"/>
-            <a:ext cx="11612880" cy="640080"/>
+            <a:off x="274320" y="1170432"/>
+            <a:ext cx="11612880" cy="566928"/>
           </a:xfrm>
           <a:prstGeom prst="rect">
             <a:avLst/>
@@ -3299,8 +3300,8 @@
         </p:nvSpPr>
         <p:spPr>
           <a:xfrm>
-            <a:off x="411480" y="1335024"/>
-            <a:ext cx="11338560" cy="512064"/>
+            <a:off x="411480" y="1225296"/>
+            <a:ext cx="11338560" cy="457200"/>
           </a:xfrm>
           <a:prstGeom prst="rect">
             <a:avLst/>
@@ -3315,14 +3316,14 @@
           <a:p>
             <a:pPr algn="l"/>
             <a:r>
-              <a:rPr sz="1200" b="1">
+              <a:rPr sz="1100" b="1">
                 <a:solidFill>
                   <a:srgbClr val="1A1A1A"/>
                 </a:solidFill>
                 <a:latin typeface="Microsoft YaHei"/>
                 <a:ea typeface="Microsoft YaHei"/>
               </a:rPr>
-              <a:t>一句话判断：Agentic 负载将推理优化目标从无状态 QPS，重构为 Session 连续性、KV Cache 命中率与 Token 级成本；PAI 以流量调度 / 引擎执行 / 全局缓存三层协同闭环，叠加智能选模实现质量对齐旗舰、综合成本约 -65%。</a:t>
+              <a:t>一句话判断：Agentic Inference 将推理从无状态 QPS 服务，重构为「长上下文 + KV 前缀命中 + Token 级流控 + 会话亲和」系统问题；PAI 以流量调度 / 引擎执行 / 全局缓存三层协同，并用 Session/Cache-Aware 调度与智能选模同时抬 TTFT/TPS、压综合成本。</a:t>
             </a:r>
           </a:p>
         </p:txBody>
@@ -3335,8 +3336,8 @@
         </p:nvSpPr>
         <p:spPr>
           <a:xfrm>
-            <a:off x="274320" y="2029968"/>
-            <a:ext cx="3749039" cy="2331720"/>
+            <a:off x="274320" y="1847088"/>
+            <a:ext cx="3749039" cy="2487168"/>
           </a:xfrm>
           <a:prstGeom prst="rect">
             <a:avLst/>
@@ -3380,8 +3381,8 @@
         </p:nvSpPr>
         <p:spPr>
           <a:xfrm>
-            <a:off x="402336" y="2121408"/>
-            <a:ext cx="3493007" cy="292608"/>
+            <a:off x="384048" y="1920240"/>
+            <a:ext cx="3529583" cy="274320"/>
           </a:xfrm>
           <a:prstGeom prst="rect">
             <a:avLst/>
@@ -3396,14 +3397,14 @@
           <a:p>
             <a:pPr algn="l"/>
             <a:r>
-              <a:rPr sz="1400" b="1">
+              <a:rPr sz="1300" b="1">
                 <a:solidFill>
                   <a:srgbClr val="8B1A2B"/>
                 </a:solidFill>
                 <a:latin typeface="Microsoft YaHei"/>
                 <a:ea typeface="Microsoft YaHei"/>
               </a:rPr>
-              <a:t>01  负载与度量重构</a:t>
+              <a:t>01  Agentic 负载四特征</a:t>
             </a:r>
           </a:p>
         </p:txBody>
@@ -3416,8 +3417,8 @@
         </p:nvSpPr>
         <p:spPr>
           <a:xfrm>
-            <a:off x="402336" y="2432304"/>
-            <a:ext cx="3493007" cy="1828800"/>
+            <a:off x="384048" y="2212848"/>
+            <a:ext cx="3529583" cy="2029968"/>
           </a:xfrm>
           <a:prstGeom prst="rect">
             <a:avLst/>
@@ -3432,69 +3433,86 @@
           <a:p>
             <a:pPr algn="l">
               <a:spcAft>
-                <a:spcPts val="200"/>
+                <a:spcPts val="100"/>
               </a:spcAft>
             </a:pPr>
             <a:r>
-              <a:rPr sz="1100" b="1">
+              <a:rPr sz="1000" b="1">
                 <a:solidFill>
                   <a:srgbClr val="1A1A1A"/>
                 </a:solidFill>
                 <a:latin typeface="Microsoft YaHei"/>
                 <a:ea typeface="Microsoft YaHei"/>
               </a:rPr>
-              <a:t>启示：调度目标函数从 QPS 切换为 Session亲和×KV命中×Token成本</a:t>
+              <a:t>技术启示：调度目标函数切到 Session×KV命中×Token成本</a:t>
             </a:r>
           </a:p>
           <a:p>
             <a:pPr algn="l">
               <a:spcAft>
-                <a:spcPts val="200"/>
+                <a:spcPts val="100"/>
               </a:spcAft>
             </a:pPr>
             <a:r>
-              <a:rPr sz="1100" b="0">
+              <a:rPr sz="1000" b="0">
                 <a:solidFill>
                   <a:srgbClr val="4A4A4A"/>
                 </a:solidFill>
                 <a:latin typeface="Microsoft YaHei"/>
                 <a:ea typeface="Microsoft YaHei"/>
               </a:rPr>
-              <a:t>• 上下文滚到数万 Token；4K 请求 KV 可超 200MB</a:t>
+              <a:t>• 长上下文：百→数万 Token；4K 请求 KV 可超 200MB</a:t>
             </a:r>
           </a:p>
           <a:p>
             <a:pPr algn="l">
               <a:spcAft>
-                <a:spcPts val="200"/>
+                <a:spcPts val="100"/>
               </a:spcAft>
             </a:pPr>
             <a:r>
-              <a:rPr sz="1100" b="0">
+              <a:rPr sz="1000" b="0">
                 <a:solidFill>
                   <a:srgbClr val="4A4A4A"/>
                 </a:solidFill>
                 <a:latin typeface="Microsoft YaHei"/>
                 <a:ea typeface="Microsoft YaHei"/>
               </a:rPr>
-              <a:t>• 前缀命中率直接决定 TTFT 与有效吞吐，需一等观测</a:t>
+              <a:t>• KV 高命中：多轮前缀重叠，命中率决定 TTFT/吞吐</a:t>
             </a:r>
           </a:p>
           <a:p>
             <a:pPr algn="l">
               <a:spcAft>
-                <a:spcPts val="200"/>
+                <a:spcPts val="100"/>
               </a:spcAft>
             </a:pPr>
             <a:r>
-              <a:rPr sz="1100" b="0">
+              <a:rPr sz="1000" b="0">
                 <a:solidFill>
                   <a:srgbClr val="4A4A4A"/>
                 </a:solidFill>
                 <a:latin typeface="Microsoft YaHei"/>
                 <a:ea typeface="Microsoft YaHei"/>
               </a:rPr>
-              <a:t>• 限流/配额按 TPM/Token，弹性伸缩保持 KV 连续</a:t>
+              <a:t>• Token 级规划：长请求成本远高于短请求，禁只用 QPS</a:t>
+            </a:r>
+          </a:p>
+          <a:p>
+            <a:pPr algn="l">
+              <a:spcAft>
+                <a:spcPts val="100"/>
+              </a:spcAft>
+            </a:pPr>
+            <a:r>
+              <a:rPr sz="1000" b="0">
+                <a:solidFill>
+                  <a:srgbClr val="4A4A4A"/>
+                </a:solidFill>
+                <a:latin typeface="Microsoft YaHei"/>
+                <a:ea typeface="Microsoft YaHei"/>
+              </a:rPr>
+              <a:t>• 有状态调度：同会话回原实例；伸缩须保持 KV 连续</a:t>
             </a:r>
           </a:p>
         </p:txBody>
@@ -3507,8 +3525,8 @@
         </p:nvSpPr>
         <p:spPr>
           <a:xfrm>
-            <a:off x="4187951" y="2029968"/>
-            <a:ext cx="3749039" cy="2331720"/>
+            <a:off x="4187951" y="1847088"/>
+            <a:ext cx="3749039" cy="2487168"/>
           </a:xfrm>
           <a:prstGeom prst="rect">
             <a:avLst/>
@@ -3552,8 +3570,8 @@
         </p:nvSpPr>
         <p:spPr>
           <a:xfrm>
-            <a:off x="4315967" y="2121408"/>
-            <a:ext cx="3493007" cy="292608"/>
+            <a:off x="4297679" y="1920240"/>
+            <a:ext cx="3529583" cy="274320"/>
           </a:xfrm>
           <a:prstGeom prst="rect">
             <a:avLst/>
@@ -3568,14 +3586,14 @@
           <a:p>
             <a:pPr algn="l"/>
             <a:r>
-              <a:rPr sz="1400" b="1">
+              <a:rPr sz="1300" b="1">
                 <a:solidFill>
                   <a:srgbClr val="8B1A2B"/>
                 </a:solidFill>
                 <a:latin typeface="Microsoft YaHei"/>
                 <a:ea typeface="Microsoft YaHei"/>
               </a:rPr>
-              <a:t>02  Serving 三层闭环</a:t>
+              <a:t>02  三层架构 × 五层路由</a:t>
             </a:r>
           </a:p>
         </p:txBody>
@@ -3588,8 +3606,8 @@
         </p:nvSpPr>
         <p:spPr>
           <a:xfrm>
-            <a:off x="4315967" y="2432304"/>
-            <a:ext cx="3493007" cy="1828800"/>
+            <a:off x="4297679" y="2212848"/>
+            <a:ext cx="3529583" cy="2029968"/>
           </a:xfrm>
           <a:prstGeom prst="rect">
             <a:avLst/>
@@ -3604,69 +3622,86 @@
           <a:p>
             <a:pPr algn="l">
               <a:spcAft>
-                <a:spcPts val="200"/>
+                <a:spcPts val="100"/>
               </a:spcAft>
             </a:pPr>
             <a:r>
-              <a:rPr sz="1100" b="1">
+              <a:rPr sz="1000" b="1">
                 <a:solidFill>
                   <a:srgbClr val="1A1A1A"/>
                 </a:solidFill>
                 <a:latin typeface="Microsoft YaHei"/>
                 <a:ea typeface="Microsoft YaHei"/>
               </a:rPr>
-              <a:t>启示：控制面路由、执行面 PD/并行、数据面全局 KV 必须同代交付</a:t>
+              <a:t>技术启示：控制面五层能力与执行/缓存面必须同代交付</a:t>
             </a:r>
           </a:p>
           <a:p>
             <a:pPr algn="l">
               <a:spcAft>
-                <a:spcPts val="200"/>
+                <a:spcPts val="100"/>
               </a:spcAft>
             </a:pPr>
             <a:r>
-              <a:rPr sz="1100" b="0">
+              <a:rPr sz="1000" b="0">
                 <a:solidFill>
                   <a:srgbClr val="4A4A4A"/>
                 </a:solidFill>
                 <a:latin typeface="Microsoft YaHei"/>
                 <a:ea typeface="Microsoft YaHei"/>
               </a:rPr>
-              <a:t>• Session/Cache-Aware 级联：亲和优先，Least-Token 兜底</a:t>
+              <a:t>• 调度层：统一 API、热更新治理、容错、智能择址、实例角色</a:t>
             </a:r>
           </a:p>
           <a:p>
             <a:pPr algn="l">
               <a:spcAft>
-                <a:spcPts val="200"/>
+                <a:spcPts val="100"/>
               </a:spcAft>
             </a:pPr>
             <a:r>
-              <a:rPr sz="1100" b="0">
+              <a:rPr sz="1000" b="0">
                 <a:solidFill>
                   <a:srgbClr val="4A4A4A"/>
                 </a:solidFill>
                 <a:latin typeface="Microsoft YaHei"/>
                 <a:ea typeface="Microsoft YaHei"/>
               </a:rPr>
-              <a:t>• 全形态 PD + TP/EP/DP Rank 感知，兼容 vLLM/SGLang</a:t>
+              <a:t>• 执行层：全形态 PD、TP/EP/DP 感知、vLLM/SGLang/自定义</a:t>
             </a:r>
           </a:p>
           <a:p>
             <a:pPr algn="l">
               <a:spcAft>
-                <a:spcPts val="200"/>
+                <a:spcPts val="100"/>
               </a:spcAft>
             </a:pPr>
             <a:r>
-              <a:rPr sz="1100" b="0">
+              <a:rPr sz="1000" b="0">
                 <a:solidFill>
                   <a:srgbClr val="4A4A4A"/>
                 </a:solidFill>
                 <a:latin typeface="Microsoft YaHei"/>
                 <a:ea typeface="Microsoft YaHei"/>
               </a:rPr>
-              <a:t>• FlashKV：DRAM/SSD 分层 + RDMA 直通，缩容升级不丢缓存</a:t>
+              <a:t>• 缓存层：DRAM+SSD 池、RDMA 直通、L1/L2/L3 命中可视</a:t>
+            </a:r>
+          </a:p>
+          <a:p>
+            <a:pPr algn="l">
+              <a:spcAft>
+                <a:spcPts val="100"/>
+              </a:spcAft>
+            </a:pPr>
+            <a:r>
+              <a:rPr sz="1000" b="0">
+                <a:solidFill>
+                  <a:srgbClr val="4A4A4A"/>
+                </a:solidFill>
+                <a:latin typeface="Microsoft YaHei"/>
+                <a:ea typeface="Microsoft YaHei"/>
+              </a:rPr>
+              <a:t>• 路由五层：入口→治理→容错→调度→Normal/P/D 实例</a:t>
             </a:r>
           </a:p>
         </p:txBody>
@@ -3679,8 +3714,8 @@
         </p:nvSpPr>
         <p:spPr>
           <a:xfrm>
-            <a:off x="8101582" y="2029968"/>
-            <a:ext cx="3749039" cy="2331720"/>
+            <a:off x="8101582" y="1847088"/>
+            <a:ext cx="3749039" cy="2487168"/>
           </a:xfrm>
           <a:prstGeom prst="rect">
             <a:avLst/>
@@ -3724,8 +3759,8 @@
         </p:nvSpPr>
         <p:spPr>
           <a:xfrm>
-            <a:off x="8229598" y="2121408"/>
-            <a:ext cx="3493007" cy="292608"/>
+            <a:off x="8211310" y="1920240"/>
+            <a:ext cx="3529583" cy="274320"/>
           </a:xfrm>
           <a:prstGeom prst="rect">
             <a:avLst/>
@@ -3740,14 +3775,14 @@
           <a:p>
             <a:pPr algn="l"/>
             <a:r>
-              <a:rPr sz="1400" b="1">
+              <a:rPr sz="1300" b="1">
                 <a:solidFill>
                   <a:srgbClr val="8B1A2B"/>
                 </a:solidFill>
                 <a:latin typeface="Microsoft YaHei"/>
                 <a:ea typeface="Microsoft YaHei"/>
               </a:rPr>
-              <a:t>03  成本与可信执行</a:t>
+              <a:t>03  亲和调度 + 智能选模</a:t>
             </a:r>
           </a:p>
         </p:txBody>
@@ -3760,8 +3795,8 @@
         </p:nvSpPr>
         <p:spPr>
           <a:xfrm>
-            <a:off x="8229598" y="2432304"/>
-            <a:ext cx="3493007" cy="1828800"/>
+            <a:off x="8211310" y="2212848"/>
+            <a:ext cx="3529583" cy="2029968"/>
           </a:xfrm>
           <a:prstGeom prst="rect">
             <a:avLst/>
@@ -3776,69 +3811,86 @@
           <a:p>
             <a:pPr algn="l">
               <a:spcAft>
-                <a:spcPts val="200"/>
+                <a:spcPts val="100"/>
               </a:spcAft>
             </a:pPr>
             <a:r>
-              <a:rPr sz="1100" b="1">
+              <a:rPr sz="1000" b="1">
                 <a:solidFill>
                   <a:srgbClr val="1A1A1A"/>
                 </a:solidFill>
                 <a:latin typeface="Microsoft YaHei"/>
                 <a:ea typeface="Microsoft YaHei"/>
               </a:rPr>
-              <a:t>启示：用难度分流做质量-成本帕累托，用 TEE 远程证明做可验证安全</a:t>
+              <a:t>技术启示：策略级联提命中，难度分流做质量-成本帕累托</a:t>
             </a:r>
           </a:p>
           <a:p>
             <a:pPr algn="l">
               <a:spcAft>
-                <a:spcPts val="200"/>
+                <a:spcPts val="100"/>
               </a:spcAft>
             </a:pPr>
             <a:r>
-              <a:rPr sz="1100" b="0">
+              <a:rPr sz="1000" b="0">
                 <a:solidFill>
                   <a:srgbClr val="4A4A4A"/>
                 </a:solidFill>
                 <a:latin typeface="Microsoft YaHei"/>
                 <a:ea typeface="Microsoft YaHei"/>
               </a:rPr>
-              <a:t>• Auto 选模：SWE-bench 82.7%≈L3，成本指数 100→35.1</a:t>
+              <a:t>• Session-Aware(300)：strict/soft，过载熔断回退</a:t>
             </a:r>
           </a:p>
           <a:p>
             <a:pPr algn="l">
               <a:spcAft>
-                <a:spcPts val="200"/>
+                <a:spcPts val="100"/>
               </a:spcAft>
             </a:pPr>
             <a:r>
-              <a:rPr sz="1100" b="0">
+              <a:rPr sz="1000" b="0">
                 <a:solidFill>
                   <a:srgbClr val="4A4A4A"/>
                 </a:solidFill>
                 <a:latin typeface="Microsoft YaHei"/>
                 <a:ea typeface="Microsoft YaHei"/>
               </a:rPr>
-              <a:t>• 跨 Region 联邦：PRIMARY 全局视图，Spot 库存透明接力</a:t>
+              <a:t>• Cache-Aware(200)：块哈希索引；Least-Token(0) 兜底</a:t>
             </a:r>
           </a:p>
           <a:p>
             <a:pPr algn="l">
               <a:spcAft>
-                <a:spcPts val="200"/>
+                <a:spcPts val="100"/>
               </a:spcAft>
             </a:pPr>
             <a:r>
-              <a:rPr sz="1100" b="0">
+              <a:rPr sz="1000" b="0">
                 <a:solidFill>
                   <a:srgbClr val="4A4A4A"/>
                 </a:solidFill>
                 <a:latin typeface="Microsoft YaHei"/>
                 <a:ea typeface="Microsoft YaHei"/>
               </a:rPr>
-              <a:t>• PAI-CC：本地加密上云 → 远程证明放行 → E2E 密态推理</a:t>
+              <a:t>• PD/DP Rank 差异化：P 追前缀，D 追负载，MoE 防局部过热</a:t>
+            </a:r>
+          </a:p>
+          <a:p>
+            <a:pPr algn="l">
+              <a:spcAft>
+                <a:spcPts val="100"/>
+              </a:spcAft>
+            </a:pPr>
+            <a:r>
+              <a:rPr sz="1000" b="0">
+                <a:solidFill>
+                  <a:srgbClr val="4A4A4A"/>
+                </a:solidFill>
+                <a:latin typeface="Microsoft YaHei"/>
+                <a:ea typeface="Microsoft YaHei"/>
+              </a:rPr>
+              <a:t>• Auto 选模 L1/L2/L3：客户端写 auto，无实例自动切候选</a:t>
             </a:r>
           </a:p>
         </p:txBody>
@@ -3851,8 +3903,8 @@
         </p:nvSpPr>
         <p:spPr>
           <a:xfrm>
-            <a:off x="274320" y="4498848"/>
-            <a:ext cx="9144000" cy="237744"/>
+            <a:off x="274320" y="4462272"/>
+            <a:ext cx="9144000" cy="219456"/>
           </a:xfrm>
           <a:prstGeom prst="rect">
             <a:avLst/>
@@ -3867,7 +3919,7 @@
           <a:p>
             <a:pPr algn="l"/>
             <a:r>
-              <a:rPr sz="1300" b="1">
+              <a:rPr sz="1200" b="1">
                 <a:solidFill>
                   <a:srgbClr val="1A1A1A"/>
                 </a:solidFill>
@@ -3887,8 +3939,8 @@
         </p:nvSpPr>
         <p:spPr>
           <a:xfrm>
-            <a:off x="274320" y="4754880"/>
-            <a:ext cx="1874519" cy="914400"/>
+            <a:off x="274320" y="4700016"/>
+            <a:ext cx="1874519" cy="868680"/>
           </a:xfrm>
           <a:prstGeom prst="rect">
             <a:avLst/>
@@ -3932,8 +3984,8 @@
         </p:nvSpPr>
         <p:spPr>
           <a:xfrm>
-            <a:off x="347472" y="4800600"/>
-            <a:ext cx="1746503" cy="201168"/>
+            <a:off x="347472" y="4736592"/>
+            <a:ext cx="1746503" cy="182880"/>
           </a:xfrm>
           <a:prstGeom prst="rect">
             <a:avLst/>
@@ -3948,7 +4000,7 @@
           <a:p>
             <a:pPr algn="l"/>
             <a:r>
-              <a:rPr sz="1000" b="0">
+              <a:rPr sz="900" b="0">
                 <a:solidFill>
                   <a:srgbClr val="6B6B6B"/>
                 </a:solidFill>
@@ -3968,8 +4020,8 @@
         </p:nvSpPr>
         <p:spPr>
           <a:xfrm>
-            <a:off x="347472" y="5010912"/>
-            <a:ext cx="1746503" cy="256032"/>
+            <a:off x="347472" y="4919472"/>
+            <a:ext cx="1746503" cy="237744"/>
           </a:xfrm>
           <a:prstGeom prst="rect">
             <a:avLst/>
@@ -3991,7 +4043,7 @@
                 <a:latin typeface="Microsoft YaHei"/>
                 <a:ea typeface="Microsoft YaHei"/>
               </a:rPr>
-              <a:t>基线 → Cache-Aware</a:t>
+              <a:t>基线→Cache-Aware</a:t>
             </a:r>
           </a:p>
         </p:txBody>
@@ -4004,7 +4056,7 @@
         </p:nvSpPr>
         <p:spPr>
           <a:xfrm>
-            <a:off x="347472" y="5257800"/>
+            <a:off x="347472" y="5157216"/>
             <a:ext cx="1746503" cy="347472"/>
           </a:xfrm>
           <a:prstGeom prst="rect">
@@ -4040,8 +4092,8 @@
         </p:nvSpPr>
         <p:spPr>
           <a:xfrm>
-            <a:off x="2240279" y="4754880"/>
-            <a:ext cx="1874519" cy="914400"/>
+            <a:off x="2240279" y="4700016"/>
+            <a:ext cx="1874519" cy="868680"/>
           </a:xfrm>
           <a:prstGeom prst="rect">
             <a:avLst/>
@@ -4085,8 +4137,8 @@
         </p:nvSpPr>
         <p:spPr>
           <a:xfrm>
-            <a:off x="2313431" y="4800600"/>
-            <a:ext cx="1746503" cy="201168"/>
+            <a:off x="2313431" y="4736592"/>
+            <a:ext cx="1746503" cy="182880"/>
           </a:xfrm>
           <a:prstGeom prst="rect">
             <a:avLst/>
@@ -4101,7 +4153,7 @@
           <a:p>
             <a:pPr algn="l"/>
             <a:r>
-              <a:rPr sz="1000" b="0">
+              <a:rPr sz="900" b="0">
                 <a:solidFill>
                   <a:srgbClr val="6B6B6B"/>
                 </a:solidFill>
@@ -4121,8 +4173,8 @@
         </p:nvSpPr>
         <p:spPr>
           <a:xfrm>
-            <a:off x="2313431" y="5010912"/>
-            <a:ext cx="1746503" cy="256032"/>
+            <a:off x="2313431" y="4919472"/>
+            <a:ext cx="1746503" cy="237744"/>
           </a:xfrm>
           <a:prstGeom prst="rect">
             <a:avLst/>
@@ -4144,7 +4196,7 @@
                 <a:latin typeface="Microsoft YaHei"/>
                 <a:ea typeface="Microsoft YaHei"/>
               </a:rPr>
-              <a:t>Cache-Aware 调度</a:t>
+              <a:t>Cache-Aware</a:t>
             </a:r>
           </a:p>
         </p:txBody>
@@ -4157,7 +4209,7 @@
         </p:nvSpPr>
         <p:spPr>
           <a:xfrm>
-            <a:off x="2313431" y="5257800"/>
+            <a:off x="2313431" y="5157216"/>
             <a:ext cx="1746503" cy="347472"/>
           </a:xfrm>
           <a:prstGeom prst="rect">
@@ -4193,8 +4245,8 @@
         </p:nvSpPr>
         <p:spPr>
           <a:xfrm>
-            <a:off x="4206238" y="4754880"/>
-            <a:ext cx="1874519" cy="914400"/>
+            <a:off x="4206238" y="4700016"/>
+            <a:ext cx="1874519" cy="868680"/>
           </a:xfrm>
           <a:prstGeom prst="rect">
             <a:avLst/>
@@ -4238,8 +4290,8 @@
         </p:nvSpPr>
         <p:spPr>
           <a:xfrm>
-            <a:off x="4279390" y="4800600"/>
-            <a:ext cx="1746503" cy="201168"/>
+            <a:off x="4279390" y="4736592"/>
+            <a:ext cx="1746503" cy="182880"/>
           </a:xfrm>
           <a:prstGeom prst="rect">
             <a:avLst/>
@@ -4254,7 +4306,7 @@
           <a:p>
             <a:pPr algn="l"/>
             <a:r>
-              <a:rPr sz="1000" b="0">
+              <a:rPr sz="900" b="0">
                 <a:solidFill>
                   <a:srgbClr val="6B6B6B"/>
                 </a:solidFill>
@@ -4274,8 +4326,8 @@
         </p:nvSpPr>
         <p:spPr>
           <a:xfrm>
-            <a:off x="4279390" y="5010912"/>
-            <a:ext cx="1746503" cy="256032"/>
+            <a:off x="4279390" y="4919472"/>
+            <a:ext cx="1746503" cy="237744"/>
           </a:xfrm>
           <a:prstGeom prst="rect">
             <a:avLst/>
@@ -4297,7 +4349,7 @@
                 <a:latin typeface="Microsoft YaHei"/>
                 <a:ea typeface="Microsoft YaHei"/>
               </a:rPr>
-              <a:t>Cache-Aware 调度</a:t>
+              <a:t>Cache-Aware</a:t>
             </a:r>
           </a:p>
         </p:txBody>
@@ -4310,7 +4362,7 @@
         </p:nvSpPr>
         <p:spPr>
           <a:xfrm>
-            <a:off x="4279390" y="5257800"/>
+            <a:off x="4279390" y="5157216"/>
             <a:ext cx="1746503" cy="347472"/>
           </a:xfrm>
           <a:prstGeom prst="rect">
@@ -4346,8 +4398,8 @@
         </p:nvSpPr>
         <p:spPr>
           <a:xfrm>
-            <a:off x="6172197" y="4754880"/>
-            <a:ext cx="1874519" cy="914400"/>
+            <a:off x="6172197" y="4700016"/>
+            <a:ext cx="1874519" cy="868680"/>
           </a:xfrm>
           <a:prstGeom prst="rect">
             <a:avLst/>
@@ -4391,8 +4443,8 @@
         </p:nvSpPr>
         <p:spPr>
           <a:xfrm>
-            <a:off x="6245349" y="4800600"/>
-            <a:ext cx="1746503" cy="201168"/>
+            <a:off x="6245349" y="4736592"/>
+            <a:ext cx="1746503" cy="182880"/>
           </a:xfrm>
           <a:prstGeom prst="rect">
             <a:avLst/>
@@ -4407,14 +4459,14 @@
           <a:p>
             <a:pPr algn="l"/>
             <a:r>
-              <a:rPr sz="1000" b="0">
+              <a:rPr sz="900" b="0">
                 <a:solidFill>
                   <a:srgbClr val="6B6B6B"/>
                 </a:solidFill>
                 <a:latin typeface="Microsoft YaHei"/>
                 <a:ea typeface="Microsoft YaHei"/>
               </a:rPr>
-              <a:t>FlashKV 命中率</a:t>
+              <a:t>选模质量</a:t>
             </a:r>
           </a:p>
         </p:txBody>
@@ -4427,8 +4479,8 @@
         </p:nvSpPr>
         <p:spPr>
           <a:xfrm>
-            <a:off x="6245349" y="5010912"/>
-            <a:ext cx="1746503" cy="256032"/>
+            <a:off x="6245349" y="4919472"/>
+            <a:ext cx="1746503" cy="237744"/>
           </a:xfrm>
           <a:prstGeom prst="rect">
             <a:avLst/>
@@ -4450,7 +4502,7 @@
                 <a:latin typeface="Microsoft YaHei"/>
                 <a:ea typeface="Microsoft YaHei"/>
               </a:rPr>
-              <a:t>再叠加全局 KV</a:t>
+              <a:t>纯L1→Auto</a:t>
             </a:r>
           </a:p>
         </p:txBody>
@@ -4463,7 +4515,7 @@
         </p:nvSpPr>
         <p:spPr>
           <a:xfrm>
-            <a:off x="6245349" y="5257800"/>
+            <a:off x="6245349" y="5157216"/>
             <a:ext cx="1746503" cy="347472"/>
           </a:xfrm>
           <a:prstGeom prst="rect">
@@ -4486,7 +4538,7 @@
                 <a:latin typeface="Microsoft YaHei"/>
                 <a:ea typeface="Microsoft YaHei"/>
               </a:rPr>
-              <a:t>78.62%→94.32%</a:t>
+              <a:t>47.3%→82.7%</a:t>
             </a:r>
           </a:p>
         </p:txBody>
@@ -4499,8 +4551,8 @@
         </p:nvSpPr>
         <p:spPr>
           <a:xfrm>
-            <a:off x="8138156" y="4754880"/>
-            <a:ext cx="1874519" cy="914400"/>
+            <a:off x="8138156" y="4700016"/>
+            <a:ext cx="1874519" cy="868680"/>
           </a:xfrm>
           <a:prstGeom prst="rect">
             <a:avLst/>
@@ -4544,8 +4596,8 @@
         </p:nvSpPr>
         <p:spPr>
           <a:xfrm>
-            <a:off x="8211308" y="4800600"/>
-            <a:ext cx="1746503" cy="201168"/>
+            <a:off x="8211308" y="4736592"/>
+            <a:ext cx="1746503" cy="182880"/>
           </a:xfrm>
           <a:prstGeom prst="rect">
             <a:avLst/>
@@ -4560,14 +4612,14 @@
           <a:p>
             <a:pPr algn="l"/>
             <a:r>
-              <a:rPr sz="1000" b="0">
+              <a:rPr sz="900" b="0">
                 <a:solidFill>
                   <a:srgbClr val="6B6B6B"/>
                 </a:solidFill>
                 <a:latin typeface="Microsoft YaHei"/>
                 <a:ea typeface="Microsoft YaHei"/>
               </a:rPr>
-              <a:t>FlashKV TTFT/TPS</a:t>
+              <a:t>选模成本指数</a:t>
             </a:r>
           </a:p>
         </p:txBody>
@@ -4580,8 +4632,8 @@
         </p:nvSpPr>
         <p:spPr>
           <a:xfrm>
-            <a:off x="8211308" y="5010912"/>
-            <a:ext cx="1746503" cy="256032"/>
+            <a:off x="8211308" y="4919472"/>
+            <a:ext cx="1746503" cy="237744"/>
           </a:xfrm>
           <a:prstGeom prst="rect">
             <a:avLst/>
@@ -4603,7 +4655,7 @@
                 <a:latin typeface="Microsoft YaHei"/>
                 <a:ea typeface="Microsoft YaHei"/>
               </a:rPr>
-              <a:t>相对前一阶段</a:t>
+              <a:t>纯L3→Auto</a:t>
             </a:r>
           </a:p>
         </p:txBody>
@@ -4616,7 +4668,7 @@
         </p:nvSpPr>
         <p:spPr>
           <a:xfrm>
-            <a:off x="8211308" y="5257800"/>
+            <a:off x="8211308" y="5157216"/>
             <a:ext cx="1746503" cy="347472"/>
           </a:xfrm>
           <a:prstGeom prst="rect">
@@ -4639,7 +4691,7 @@
                 <a:latin typeface="Microsoft YaHei"/>
                 <a:ea typeface="Microsoft YaHei"/>
               </a:rPr>
-              <a:t>-25% / +40%</a:t>
+              <a:t>100→35.1(-65%)</a:t>
             </a:r>
           </a:p>
         </p:txBody>
@@ -4652,8 +4704,8 @@
         </p:nvSpPr>
         <p:spPr>
           <a:xfrm>
-            <a:off x="10104115" y="4754880"/>
-            <a:ext cx="1874519" cy="914400"/>
+            <a:off x="10104115" y="4700016"/>
+            <a:ext cx="1874519" cy="868680"/>
           </a:xfrm>
           <a:prstGeom prst="rect">
             <a:avLst/>
@@ -4697,8 +4749,8 @@
         </p:nvSpPr>
         <p:spPr>
           <a:xfrm>
-            <a:off x="10177267" y="4800600"/>
-            <a:ext cx="1746503" cy="201168"/>
+            <a:off x="10177267" y="4736592"/>
+            <a:ext cx="1746503" cy="182880"/>
           </a:xfrm>
           <a:prstGeom prst="rect">
             <a:avLst/>
@@ -4713,14 +4765,14 @@
           <a:p>
             <a:pPr algn="l"/>
             <a:r>
-              <a:rPr sz="1000" b="0">
+              <a:rPr sz="900" b="0">
                 <a:solidFill>
                   <a:srgbClr val="6B6B6B"/>
                 </a:solidFill>
                 <a:latin typeface="Microsoft YaHei"/>
                 <a:ea typeface="Microsoft YaHei"/>
               </a:rPr>
-              <a:t>智能选模成本</a:t>
+              <a:t>流量承接</a:t>
             </a:r>
           </a:p>
         </p:txBody>
@@ -4733,8 +4785,8 @@
         </p:nvSpPr>
         <p:spPr>
           <a:xfrm>
-            <a:off x="10177267" y="5010912"/>
-            <a:ext cx="1746503" cy="256032"/>
+            <a:off x="10177267" y="4919472"/>
+            <a:ext cx="1746503" cy="237744"/>
           </a:xfrm>
           <a:prstGeom prst="rect">
             <a:avLst/>
@@ -4756,7 +4808,7 @@
                 <a:latin typeface="Microsoft YaHei"/>
                 <a:ea typeface="Microsoft YaHei"/>
               </a:rPr>
-              <a:t>纯 L3 → Auto</a:t>
+              <a:t>L1+L2 占比</a:t>
             </a:r>
           </a:p>
         </p:txBody>
@@ -4769,7 +4821,7 @@
         </p:nvSpPr>
         <p:spPr>
           <a:xfrm>
-            <a:off x="10177267" y="5257800"/>
+            <a:off x="10177267" y="5157216"/>
             <a:ext cx="1746503" cy="347472"/>
           </a:xfrm>
           <a:prstGeom prst="rect">
@@ -4792,7 +4844,7 @@
                 <a:latin typeface="Microsoft YaHei"/>
                 <a:ea typeface="Microsoft YaHei"/>
               </a:rPr>
-              <a:t>-65%</a:t>
+              <a:t>85%+</a:t>
             </a:r>
           </a:p>
         </p:txBody>
@@ -4805,8 +4857,8 @@
         </p:nvSpPr>
         <p:spPr>
           <a:xfrm>
-            <a:off x="0" y="5833872"/>
-            <a:ext cx="12191695" cy="1024128"/>
+            <a:off x="0" y="5779008"/>
+            <a:ext cx="12191695" cy="1078992"/>
           </a:xfrm>
           <a:prstGeom prst="rect">
             <a:avLst/>
@@ -4848,7 +4900,7 @@
         </p:nvSpPr>
         <p:spPr>
           <a:xfrm>
-            <a:off x="320040" y="5888736"/>
+            <a:off x="320040" y="5833872"/>
             <a:ext cx="11521440" cy="502920"/>
           </a:xfrm>
           <a:prstGeom prst="rect">
@@ -4871,7 +4923,7 @@
                 <a:latin typeface="Microsoft YaHei"/>
                 <a:ea typeface="Microsoft YaHei"/>
               </a:rPr>
-              <a:t>技术启示：将 Session 亲和与 KV 命中率写入调度 SLO/告警；以「智能路由 + PD/并行感知引擎 + 全局 KV」替代单点算子优化；用难度分流选模固化质量-成本帕累托；用全局 KV/模型分发消除缩容与切换带来的冷启动税；用 TEE+远程证明将推理安全从承诺式升级为可验证执行。</a:t>
+              <a:t>技术启示：把 Session 亲和、KV 命中率、TPM/Token 配额写入调度 SLO；用「五层路由 + PD/并行感知引擎 + 全局 KV」替代单点算子优化；用难度分流选模固化质量-成本帕累托，让旗舰模型只承接难题流量。</a:t>
             </a:r>
           </a:p>
         </p:txBody>
@@ -4884,8 +4936,8 @@
         </p:nvSpPr>
         <p:spPr>
           <a:xfrm>
-            <a:off x="320040" y="6382512"/>
-            <a:ext cx="11521440" cy="256032"/>
+            <a:off x="320040" y="6309360"/>
+            <a:ext cx="11521440" cy="237744"/>
           </a:xfrm>
           <a:prstGeom prst="rect">
             <a:avLst/>
@@ -4907,7 +4959,1900 @@
                 <a:latin typeface="Microsoft YaHei"/>
                 <a:ea typeface="Microsoft YaHei"/>
               </a:rPr>
-              <a:t>来源：云栖大会｜阿里云 PAI《Agentic Inference：推理系统的全链路优化》</a:t>
+              <a:t>来源：云栖大会｜阿里云 PAI《Agentic Inference：推理系统的全链路优化》· 覆盖第1–5章</a:t>
+            </a:r>
+          </a:p>
+        </p:txBody>
+      </p:sp>
+    </p:spTree>
+  </p:cSld>
+  <p:clrMapOvr>
+    <a:masterClrMapping/>
+  </p:clrMapOvr>
+</p:sld>
+</file>
+
+<file path=ppt/slides/slide2.xml><?xml version="1.0" encoding="utf-8"?>
+<p:sld xmlns:a="http://schemas.openxmlformats.org/drawingml/2006/main" xmlns:p="http://schemas.openxmlformats.org/presentationml/2006/main" xmlns:r="http://schemas.openxmlformats.org/officeDocument/2006/relationships">
+  <p:cSld>
+    <p:spTree>
+      <p:nvGrpSpPr>
+        <p:cNvPr id="1" name=""/>
+        <p:cNvGrpSpPr/>
+        <p:nvPr/>
+      </p:nvGrpSpPr>
+      <p:grpSpPr/>
+      <p:sp>
+        <p:nvSpPr>
+          <p:cNvPr id="2" name="Rectangle 1"/>
+          <p:cNvSpPr/>
+          <p:nvPr/>
+        </p:nvSpPr>
+        <p:spPr>
+          <a:xfrm>
+            <a:off x="0" y="0"/>
+            <a:ext cx="12191695" cy="6858000"/>
+          </a:xfrm>
+          <a:prstGeom prst="rect">
+            <a:avLst/>
+          </a:prstGeom>
+          <a:solidFill>
+            <a:srgbClr val="F5F7F9"/>
+          </a:solidFill>
+          <a:ln>
+            <a:noFill/>
+          </a:ln>
+        </p:spPr>
+        <p:style>
+          <a:lnRef idx="1">
+            <a:schemeClr val="accent1"/>
+          </a:lnRef>
+          <a:fillRef idx="3">
+            <a:schemeClr val="accent1"/>
+          </a:fillRef>
+          <a:effectRef idx="2">
+            <a:schemeClr val="accent1"/>
+          </a:effectRef>
+          <a:fontRef idx="minor">
+            <a:schemeClr val="lt1"/>
+          </a:fontRef>
+        </p:style>
+        <p:txBody>
+          <a:bodyPr rtlCol="0" anchor="ctr"/>
+          <a:lstStyle/>
+          <a:p>
+            <a:pPr algn="ctr"/>
+          </a:p>
+        </p:txBody>
+      </p:sp>
+      <p:sp>
+        <p:nvSpPr>
+          <p:cNvPr id="3" name="Rectangle 2"/>
+          <p:cNvSpPr/>
+          <p:nvPr/>
+        </p:nvSpPr>
+        <p:spPr>
+          <a:xfrm>
+            <a:off x="0" y="0"/>
+            <a:ext cx="12191695" cy="1024128"/>
+          </a:xfrm>
+          <a:prstGeom prst="rect">
+            <a:avLst/>
+          </a:prstGeom>
+          <a:solidFill>
+            <a:srgbClr val="FFFFFF"/>
+          </a:solidFill>
+          <a:ln>
+            <a:noFill/>
+          </a:ln>
+        </p:spPr>
+        <p:style>
+          <a:lnRef idx="1">
+            <a:schemeClr val="accent1"/>
+          </a:lnRef>
+          <a:fillRef idx="3">
+            <a:schemeClr val="accent1"/>
+          </a:fillRef>
+          <a:effectRef idx="2">
+            <a:schemeClr val="accent1"/>
+          </a:effectRef>
+          <a:fontRef idx="minor">
+            <a:schemeClr val="lt1"/>
+          </a:fontRef>
+        </p:style>
+        <p:txBody>
+          <a:bodyPr rtlCol="0" anchor="ctr"/>
+          <a:lstStyle/>
+          <a:p>
+            <a:pPr algn="ctr"/>
+          </a:p>
+        </p:txBody>
+      </p:sp>
+      <p:sp>
+        <p:nvSpPr>
+          <p:cNvPr id="4" name="TextBox 3"/>
+          <p:cNvSpPr txBox="1"/>
+          <p:nvPr/>
+        </p:nvSpPr>
+        <p:spPr>
+          <a:xfrm>
+            <a:off x="320040" y="73152"/>
+            <a:ext cx="11521440" cy="219456"/>
+          </a:xfrm>
+          <a:prstGeom prst="rect">
+            <a:avLst/>
+          </a:prstGeom>
+          <a:noFill/>
+        </p:spPr>
+        <p:txBody>
+          <a:bodyPr wrap="square">
+            <a:spAutoFit/>
+          </a:bodyPr>
+          <a:lstStyle/>
+          <a:p>
+            <a:pPr algn="l"/>
+            <a:r>
+              <a:rPr sz="1100" b="0">
+                <a:solidFill>
+                  <a:srgbClr val="6B6B6B"/>
+                </a:solidFill>
+                <a:latin typeface="Microsoft YaHei"/>
+                <a:ea typeface="Microsoft YaHei"/>
+              </a:rPr>
+              <a:t>05 · 续 · 平台能力闭环｜第 2/2 页</a:t>
+            </a:r>
+          </a:p>
+        </p:txBody>
+      </p:sp>
+      <p:sp>
+        <p:nvSpPr>
+          <p:cNvPr id="5" name="TextBox 4"/>
+          <p:cNvSpPr txBox="1"/>
+          <p:nvPr/>
+        </p:nvSpPr>
+        <p:spPr>
+          <a:xfrm>
+            <a:off x="320040" y="310896"/>
+            <a:ext cx="11521440" cy="585216"/>
+          </a:xfrm>
+          <a:prstGeom prst="rect">
+            <a:avLst/>
+          </a:prstGeom>
+          <a:noFill/>
+        </p:spPr>
+        <p:txBody>
+          <a:bodyPr wrap="square">
+            <a:spAutoFit/>
+          </a:bodyPr>
+          <a:lstStyle/>
+          <a:p>
+            <a:pPr algn="l"/>
+            <a:r>
+              <a:rPr sz="1600" b="1">
+                <a:solidFill>
+                  <a:srgbClr val="1A1A1A"/>
+                </a:solidFill>
+                <a:latin typeface="Microsoft YaHei"/>
+                <a:ea typeface="Microsoft YaHei"/>
+              </a:rPr>
+              <a:t>从「联邦·可观测·治理·引擎·FlashKV·分发·机密计算」看 PAI 将 Agentic 推理做成可运营平台能力</a:t>
+            </a:r>
+          </a:p>
+        </p:txBody>
+      </p:sp>
+      <p:sp>
+        <p:nvSpPr>
+          <p:cNvPr id="6" name="Rectangle 5"/>
+          <p:cNvSpPr/>
+          <p:nvPr/>
+        </p:nvSpPr>
+        <p:spPr>
+          <a:xfrm>
+            <a:off x="274320" y="1078992"/>
+            <a:ext cx="11612880" cy="530352"/>
+          </a:xfrm>
+          <a:prstGeom prst="rect">
+            <a:avLst/>
+          </a:prstGeom>
+          <a:solidFill>
+            <a:srgbClr val="FFFFFF"/>
+          </a:solidFill>
+          <a:ln w="12700">
+            <a:solidFill>
+              <a:srgbClr val="D0D8DE"/>
+            </a:solidFill>
+          </a:ln>
+        </p:spPr>
+        <p:style>
+          <a:lnRef idx="1">
+            <a:schemeClr val="accent1"/>
+          </a:lnRef>
+          <a:fillRef idx="3">
+            <a:schemeClr val="accent1"/>
+          </a:fillRef>
+          <a:effectRef idx="2">
+            <a:schemeClr val="accent1"/>
+          </a:effectRef>
+          <a:fontRef idx="minor">
+            <a:schemeClr val="lt1"/>
+          </a:fontRef>
+        </p:style>
+        <p:txBody>
+          <a:bodyPr rtlCol="0" anchor="ctr"/>
+          <a:lstStyle/>
+          <a:p>
+            <a:pPr algn="ctr"/>
+          </a:p>
+        </p:txBody>
+      </p:sp>
+      <p:sp>
+        <p:nvSpPr>
+          <p:cNvPr id="7" name="TextBox 6"/>
+          <p:cNvSpPr txBox="1"/>
+          <p:nvPr/>
+        </p:nvSpPr>
+        <p:spPr>
+          <a:xfrm>
+            <a:off x="411480" y="1133856"/>
+            <a:ext cx="11338560" cy="438912"/>
+          </a:xfrm>
+          <a:prstGeom prst="rect">
+            <a:avLst/>
+          </a:prstGeom>
+          <a:noFill/>
+        </p:spPr>
+        <p:txBody>
+          <a:bodyPr wrap="square">
+            <a:spAutoFit/>
+          </a:bodyPr>
+          <a:lstStyle/>
+          <a:p>
+            <a:pPr algn="l"/>
+            <a:r>
+              <a:rPr sz="1100" b="1">
+                <a:solidFill>
+                  <a:srgbClr val="1A1A1A"/>
+                </a:solidFill>
+                <a:latin typeface="Microsoft YaHei"/>
+                <a:ea typeface="Microsoft YaHei"/>
+              </a:rPr>
+              <a:t>一句话判断：在调度与选模之上，PAI 补齐跨 Region 库存联邦、Token/Coding 订阅闸门、可用性感知灰度、离线批量错峰、录制回放资产化，以及 FlashKV/CacheFS 与 TEE 可验证安全，形成生产级 Agentic Serving。</a:t>
+            </a:r>
+          </a:p>
+        </p:txBody>
+      </p:sp>
+      <p:sp>
+        <p:nvSpPr>
+          <p:cNvPr id="8" name="Rectangle 7"/>
+          <p:cNvSpPr/>
+          <p:nvPr/>
+        </p:nvSpPr>
+        <p:spPr>
+          <a:xfrm>
+            <a:off x="274320" y="1737360"/>
+            <a:ext cx="3749039" cy="2542032"/>
+          </a:xfrm>
+          <a:prstGeom prst="rect">
+            <a:avLst/>
+          </a:prstGeom>
+          <a:solidFill>
+            <a:srgbClr val="FFFFFF"/>
+          </a:solidFill>
+          <a:ln w="12700">
+            <a:solidFill>
+              <a:srgbClr val="D0D8DE"/>
+            </a:solidFill>
+          </a:ln>
+        </p:spPr>
+        <p:style>
+          <a:lnRef idx="1">
+            <a:schemeClr val="accent1"/>
+          </a:lnRef>
+          <a:fillRef idx="3">
+            <a:schemeClr val="accent1"/>
+          </a:fillRef>
+          <a:effectRef idx="2">
+            <a:schemeClr val="accent1"/>
+          </a:effectRef>
+          <a:fontRef idx="minor">
+            <a:schemeClr val="lt1"/>
+          </a:fontRef>
+        </p:style>
+        <p:txBody>
+          <a:bodyPr rtlCol="0" anchor="ctr"/>
+          <a:lstStyle/>
+          <a:p>
+            <a:pPr algn="ctr"/>
+          </a:p>
+        </p:txBody>
+      </p:sp>
+      <p:sp>
+        <p:nvSpPr>
+          <p:cNvPr id="9" name="TextBox 8"/>
+          <p:cNvSpPr txBox="1"/>
+          <p:nvPr/>
+        </p:nvSpPr>
+        <p:spPr>
+          <a:xfrm>
+            <a:off x="384048" y="1810512"/>
+            <a:ext cx="3529583" cy="274320"/>
+          </a:xfrm>
+          <a:prstGeom prst="rect">
+            <a:avLst/>
+          </a:prstGeom>
+          <a:noFill/>
+        </p:spPr>
+        <p:txBody>
+          <a:bodyPr wrap="square">
+            <a:spAutoFit/>
+          </a:bodyPr>
+          <a:lstStyle/>
+          <a:p>
+            <a:pPr algn="l"/>
+            <a:r>
+              <a:rPr sz="1300" b="1">
+                <a:solidFill>
+                  <a:srgbClr val="8B1A2B"/>
+                </a:solidFill>
+                <a:latin typeface="Microsoft YaHei"/>
+                <a:ea typeface="Microsoft YaHei"/>
+              </a:rPr>
+              <a:t>04  联邦·观测·流控·灰度</a:t>
+            </a:r>
+          </a:p>
+        </p:txBody>
+      </p:sp>
+      <p:sp>
+        <p:nvSpPr>
+          <p:cNvPr id="10" name="TextBox 9"/>
+          <p:cNvSpPr txBox="1"/>
+          <p:nvPr/>
+        </p:nvSpPr>
+        <p:spPr>
+          <a:xfrm>
+            <a:off x="384048" y="2103120"/>
+            <a:ext cx="3529583" cy="2084832"/>
+          </a:xfrm>
+          <a:prstGeom prst="rect">
+            <a:avLst/>
+          </a:prstGeom>
+          <a:noFill/>
+        </p:spPr>
+        <p:txBody>
+          <a:bodyPr wrap="square">
+            <a:spAutoFit/>
+          </a:bodyPr>
+          <a:lstStyle/>
+          <a:p>
+            <a:pPr algn="l">
+              <a:spcAft>
+                <a:spcPts val="100"/>
+              </a:spcAft>
+            </a:pPr>
+            <a:r>
+              <a:rPr sz="1000" b="1">
+                <a:solidFill>
+                  <a:srgbClr val="1A1A1A"/>
+                </a:solidFill>
+                <a:latin typeface="Microsoft YaHei"/>
+                <a:ea typeface="Microsoft YaHei"/>
+              </a:rPr>
+              <a:t>技术启示：库存、计量、发布必须进入控制面默认能力</a:t>
+            </a:r>
+          </a:p>
+          <a:p>
+            <a:pPr algn="l">
+              <a:spcAft>
+                <a:spcPts val="100"/>
+              </a:spcAft>
+            </a:pPr>
+            <a:r>
+              <a:rPr sz="1000" b="0">
+                <a:solidFill>
+                  <a:srgbClr val="4A4A4A"/>
+                </a:solidFill>
+                <a:latin typeface="Microsoft YaHei"/>
+                <a:ea typeface="Microsoft YaHei"/>
+              </a:rPr>
+              <a:t>• 联邦：PRIMARY 全局 Watch；成员区按实例 ID 透明转发</a:t>
+            </a:r>
+          </a:p>
+          <a:p>
+            <a:pPr algn="l">
+              <a:spcAft>
+                <a:spcPts val="100"/>
+              </a:spcAft>
+            </a:pPr>
+            <a:r>
+              <a:rPr sz="1000" b="0">
+                <a:solidFill>
+                  <a:srgbClr val="4A4A4A"/>
+                </a:solidFill>
+                <a:latin typeface="Microsoft YaHei"/>
+                <a:ea typeface="Microsoft YaHei"/>
+              </a:rPr>
+              <a:t>• 观测：TTFT/TPOT/排队分位 + L1/L2/L3 命中 + 实例画像</a:t>
+            </a:r>
+          </a:p>
+          <a:p>
+            <a:pPr algn="l">
+              <a:spcAft>
+                <a:spcPts val="100"/>
+              </a:spcAft>
+            </a:pPr>
+            <a:r>
+              <a:rPr sz="1000" b="0">
+                <a:solidFill>
+                  <a:srgbClr val="4A4A4A"/>
+                </a:solidFill>
+                <a:latin typeface="Microsoft YaHei"/>
+                <a:ea typeface="Microsoft YaHei"/>
+              </a:rPr>
+              <a:t>• 流控：Coding/Token Plan；时段/并发/RPM·TPM/周期四闸门</a:t>
+            </a:r>
+          </a:p>
+          <a:p>
+            <a:pPr algn="l">
+              <a:spcAft>
+                <a:spcPts val="100"/>
+              </a:spcAft>
+            </a:pPr>
+            <a:r>
+              <a:rPr sz="1000" b="0">
+                <a:solidFill>
+                  <a:srgbClr val="4A4A4A"/>
+                </a:solidFill>
+                <a:latin typeface="Microsoft YaHei"/>
+                <a:ea typeface="Microsoft YaHei"/>
+              </a:rPr>
+              <a:t>• 灰度：权重即生命周期；可用性感知；PD 配对完整性校验</a:t>
+            </a:r>
+          </a:p>
+        </p:txBody>
+      </p:sp>
+      <p:sp>
+        <p:nvSpPr>
+          <p:cNvPr id="11" name="Rectangle 10"/>
+          <p:cNvSpPr/>
+          <p:nvPr/>
+        </p:nvSpPr>
+        <p:spPr>
+          <a:xfrm>
+            <a:off x="4187951" y="1737360"/>
+            <a:ext cx="3749039" cy="2542032"/>
+          </a:xfrm>
+          <a:prstGeom prst="rect">
+            <a:avLst/>
+          </a:prstGeom>
+          <a:solidFill>
+            <a:srgbClr val="FFFFFF"/>
+          </a:solidFill>
+          <a:ln w="12700">
+            <a:solidFill>
+              <a:srgbClr val="D0D8DE"/>
+            </a:solidFill>
+          </a:ln>
+        </p:spPr>
+        <p:style>
+          <a:lnRef idx="1">
+            <a:schemeClr val="accent1"/>
+          </a:lnRef>
+          <a:fillRef idx="3">
+            <a:schemeClr val="accent1"/>
+          </a:fillRef>
+          <a:effectRef idx="2">
+            <a:schemeClr val="accent1"/>
+          </a:effectRef>
+          <a:fontRef idx="minor">
+            <a:schemeClr val="lt1"/>
+          </a:fontRef>
+        </p:style>
+        <p:txBody>
+          <a:bodyPr rtlCol="0" anchor="ctr"/>
+          <a:lstStyle/>
+          <a:p>
+            <a:pPr algn="ctr"/>
+          </a:p>
+        </p:txBody>
+      </p:sp>
+      <p:sp>
+        <p:nvSpPr>
+          <p:cNvPr id="12" name="TextBox 11"/>
+          <p:cNvSpPr txBox="1"/>
+          <p:nvPr/>
+        </p:nvSpPr>
+        <p:spPr>
+          <a:xfrm>
+            <a:off x="4297679" y="1810512"/>
+            <a:ext cx="3529583" cy="274320"/>
+          </a:xfrm>
+          <a:prstGeom prst="rect">
+            <a:avLst/>
+          </a:prstGeom>
+          <a:noFill/>
+        </p:spPr>
+        <p:txBody>
+          <a:bodyPr wrap="square">
+            <a:spAutoFit/>
+          </a:bodyPr>
+          <a:lstStyle/>
+          <a:p>
+            <a:pPr algn="l"/>
+            <a:r>
+              <a:rPr sz="1300" b="1">
+                <a:solidFill>
+                  <a:srgbClr val="8B1A2B"/>
+                </a:solidFill>
+                <a:latin typeface="Microsoft YaHei"/>
+                <a:ea typeface="Microsoft YaHei"/>
+              </a:rPr>
+              <a:t>05  批量·回放·引擎 PD</a:t>
+            </a:r>
+          </a:p>
+        </p:txBody>
+      </p:sp>
+      <p:sp>
+        <p:nvSpPr>
+          <p:cNvPr id="13" name="TextBox 12"/>
+          <p:cNvSpPr txBox="1"/>
+          <p:nvPr/>
+        </p:nvSpPr>
+        <p:spPr>
+          <a:xfrm>
+            <a:off x="4297679" y="2103120"/>
+            <a:ext cx="3529583" cy="2084832"/>
+          </a:xfrm>
+          <a:prstGeom prst="rect">
+            <a:avLst/>
+          </a:prstGeom>
+          <a:noFill/>
+        </p:spPr>
+        <p:txBody>
+          <a:bodyPr wrap="square">
+            <a:spAutoFit/>
+          </a:bodyPr>
+          <a:lstStyle/>
+          <a:p>
+            <a:pPr algn="l">
+              <a:spcAft>
+                <a:spcPts val="100"/>
+              </a:spcAft>
+            </a:pPr>
+            <a:r>
+              <a:rPr sz="1000" b="1">
+                <a:solidFill>
+                  <a:srgbClr val="1A1A1A"/>
+                </a:solidFill>
+                <a:latin typeface="Microsoft YaHei"/>
+                <a:ea typeface="Microsoft YaHei"/>
+              </a:rPr>
+              <a:t>技术启示：流量资产化 + 全形态 PD 统一接入，降低发布与评测成本</a:t>
+            </a:r>
+          </a:p>
+          <a:p>
+            <a:pPr algn="l">
+              <a:spcAft>
+                <a:spcPts val="100"/>
+              </a:spcAft>
+            </a:pPr>
+            <a:r>
+              <a:rPr sz="1000" b="0">
+                <a:solidFill>
+                  <a:srgbClr val="4A4A4A"/>
+                </a:solidFill>
+                <a:latin typeface="Microsoft YaHei"/>
+                <a:ea typeface="Microsoft YaHei"/>
+              </a:rPr>
+              <a:t>• 批量：≤5万行/200MB；高峰让路、夜间吃尽闲置 GPU</a:t>
+            </a:r>
+          </a:p>
+          <a:p>
+            <a:pPr algn="l">
+              <a:spcAft>
+                <a:spcPts val="100"/>
+              </a:spcAft>
+            </a:pPr>
+            <a:r>
+              <a:rPr sz="1000" b="0">
+                <a:solidFill>
+                  <a:srgbClr val="4A4A4A"/>
+                </a:solidFill>
+                <a:latin typeface="Microsoft YaHei"/>
+                <a:ea typeface="Microsoft YaHei"/>
+              </a:rPr>
+              <a:t>• 录制回放：字节级保真 + 原节奏；发布前用真实流量验收</a:t>
+            </a:r>
+          </a:p>
+          <a:p>
+            <a:pPr algn="l">
+              <a:spcAft>
+                <a:spcPts val="100"/>
+              </a:spcAft>
+            </a:pPr>
+            <a:r>
+              <a:rPr sz="1000" b="0">
+                <a:solidFill>
+                  <a:srgbClr val="4A4A4A"/>
+                </a:solidFill>
+                <a:latin typeface="Microsoft YaHei"/>
+                <a:ea typeface="Microsoft YaHei"/>
+              </a:rPr>
+              <a:t>• PD 三模式：Prefill代理 / 网关调度 / Decode主导 全兼容</a:t>
+            </a:r>
+          </a:p>
+          <a:p>
+            <a:pPr algn="l">
+              <a:spcAft>
+                <a:spcPts val="100"/>
+              </a:spcAft>
+            </a:pPr>
+            <a:r>
+              <a:rPr sz="1000" b="0">
+                <a:solidFill>
+                  <a:srgbClr val="4A4A4A"/>
+                </a:solidFill>
+                <a:latin typeface="Microsoft YaHei"/>
+                <a:ea typeface="Microsoft YaHei"/>
+              </a:rPr>
+              <a:t>• 并行感知：P→TP；D→DP Rank；MoE 防局部过热</a:t>
+            </a:r>
+          </a:p>
+        </p:txBody>
+      </p:sp>
+      <p:sp>
+        <p:nvSpPr>
+          <p:cNvPr id="14" name="Rectangle 13"/>
+          <p:cNvSpPr/>
+          <p:nvPr/>
+        </p:nvSpPr>
+        <p:spPr>
+          <a:xfrm>
+            <a:off x="8101582" y="1737360"/>
+            <a:ext cx="3749039" cy="2542032"/>
+          </a:xfrm>
+          <a:prstGeom prst="rect">
+            <a:avLst/>
+          </a:prstGeom>
+          <a:solidFill>
+            <a:srgbClr val="FFFFFF"/>
+          </a:solidFill>
+          <a:ln w="12700">
+            <a:solidFill>
+              <a:srgbClr val="D0D8DE"/>
+            </a:solidFill>
+          </a:ln>
+        </p:spPr>
+        <p:style>
+          <a:lnRef idx="1">
+            <a:schemeClr val="accent1"/>
+          </a:lnRef>
+          <a:fillRef idx="3">
+            <a:schemeClr val="accent1"/>
+          </a:fillRef>
+          <a:effectRef idx="2">
+            <a:schemeClr val="accent1"/>
+          </a:effectRef>
+          <a:fontRef idx="minor">
+            <a:schemeClr val="lt1"/>
+          </a:fontRef>
+        </p:style>
+        <p:txBody>
+          <a:bodyPr rtlCol="0" anchor="ctr"/>
+          <a:lstStyle/>
+          <a:p>
+            <a:pPr algn="ctr"/>
+          </a:p>
+        </p:txBody>
+      </p:sp>
+      <p:sp>
+        <p:nvSpPr>
+          <p:cNvPr id="15" name="TextBox 14"/>
+          <p:cNvSpPr txBox="1"/>
+          <p:nvPr/>
+        </p:nvSpPr>
+        <p:spPr>
+          <a:xfrm>
+            <a:off x="8211310" y="1810512"/>
+            <a:ext cx="3529583" cy="274320"/>
+          </a:xfrm>
+          <a:prstGeom prst="rect">
+            <a:avLst/>
+          </a:prstGeom>
+          <a:noFill/>
+        </p:spPr>
+        <p:txBody>
+          <a:bodyPr wrap="square">
+            <a:spAutoFit/>
+          </a:bodyPr>
+          <a:lstStyle/>
+          <a:p>
+            <a:pPr algn="l"/>
+            <a:r>
+              <a:rPr sz="1300" b="1">
+                <a:solidFill>
+                  <a:srgbClr val="8B1A2B"/>
+                </a:solidFill>
+                <a:latin typeface="Microsoft YaHei"/>
+                <a:ea typeface="Microsoft YaHei"/>
+              </a:rPr>
+              <a:t>06  FlashKV·分发·机密计算</a:t>
+            </a:r>
+          </a:p>
+        </p:txBody>
+      </p:sp>
+      <p:sp>
+        <p:nvSpPr>
+          <p:cNvPr id="16" name="TextBox 15"/>
+          <p:cNvSpPr txBox="1"/>
+          <p:nvPr/>
+        </p:nvSpPr>
+        <p:spPr>
+          <a:xfrm>
+            <a:off x="8211310" y="2103120"/>
+            <a:ext cx="3529583" cy="2084832"/>
+          </a:xfrm>
+          <a:prstGeom prst="rect">
+            <a:avLst/>
+          </a:prstGeom>
+          <a:noFill/>
+        </p:spPr>
+        <p:txBody>
+          <a:bodyPr wrap="square">
+            <a:spAutoFit/>
+          </a:bodyPr>
+          <a:lstStyle/>
+          <a:p>
+            <a:pPr algn="l">
+              <a:spcAft>
+                <a:spcPts val="100"/>
+              </a:spcAft>
+            </a:pPr>
+            <a:r>
+              <a:rPr sz="1000" b="1">
+                <a:solidFill>
+                  <a:srgbClr val="1A1A1A"/>
+                </a:solidFill>
+                <a:latin typeface="Microsoft YaHei"/>
+                <a:ea typeface="Microsoft YaHei"/>
+              </a:rPr>
+              <a:t>技术启示：消除弹性税与冷启动税，并把安全升级为可验证执行</a:t>
+            </a:r>
+          </a:p>
+          <a:p>
+            <a:pPr algn="l">
+              <a:spcAft>
+                <a:spcPts val="100"/>
+              </a:spcAft>
+            </a:pPr>
+            <a:r>
+              <a:rPr sz="1000" b="0">
+                <a:solidFill>
+                  <a:srgbClr val="4A4A4A"/>
+                </a:solidFill>
+                <a:latin typeface="Microsoft YaHei"/>
+                <a:ea typeface="Microsoft YaHei"/>
+              </a:rPr>
+              <a:t>• FlashKV：引擎只留活跃 KV；DRAM/SSD + RDMA 零拷贝</a:t>
+            </a:r>
+          </a:p>
+          <a:p>
+            <a:pPr algn="l">
+              <a:spcAft>
+                <a:spcPts val="100"/>
+              </a:spcAft>
+            </a:pPr>
+            <a:r>
+              <a:rPr sz="1000" b="0">
+                <a:solidFill>
+                  <a:srgbClr val="4A4A4A"/>
+                </a:solidFill>
+                <a:latin typeface="Microsoft YaHei"/>
+                <a:ea typeface="Microsoft YaHei"/>
+              </a:rPr>
+              <a:t>• 命中再升：78.62%→94.32%；TTFT -25%；TPS +40%</a:t>
+            </a:r>
+          </a:p>
+          <a:p>
+            <a:pPr algn="l">
+              <a:spcAft>
+                <a:spcPts val="100"/>
+              </a:spcAft>
+            </a:pPr>
+            <a:r>
+              <a:rPr sz="1000" b="0">
+                <a:solidFill>
+                  <a:srgbClr val="4A4A4A"/>
+                </a:solidFill>
+                <a:latin typeface="Microsoft YaHei"/>
+                <a:ea typeface="Microsoft YaHei"/>
+              </a:rPr>
+              <a:t>• CacheFS/CacheRoot：P2P+中心缓存，加载数十分钟→秒级</a:t>
+            </a:r>
+          </a:p>
+          <a:p>
+            <a:pPr algn="l">
+              <a:spcAft>
+                <a:spcPts val="100"/>
+              </a:spcAft>
+            </a:pPr>
+            <a:r>
+              <a:rPr sz="1000" b="0">
+                <a:solidFill>
+                  <a:srgbClr val="4A4A4A"/>
+                </a:solidFill>
+                <a:latin typeface="Microsoft YaHei"/>
+                <a:ea typeface="Microsoft YaHei"/>
+              </a:rPr>
+              <a:t>• PAI-CC：本地加密上云→远程证明放行→TEE 内端到端密态</a:t>
+            </a:r>
+          </a:p>
+        </p:txBody>
+      </p:sp>
+      <p:sp>
+        <p:nvSpPr>
+          <p:cNvPr id="17" name="TextBox 16"/>
+          <p:cNvSpPr txBox="1"/>
+          <p:nvPr/>
+        </p:nvSpPr>
+        <p:spPr>
+          <a:xfrm>
+            <a:off x="274320" y="4407408"/>
+            <a:ext cx="9144000" cy="219456"/>
+          </a:xfrm>
+          <a:prstGeom prst="rect">
+            <a:avLst/>
+          </a:prstGeom>
+          <a:noFill/>
+        </p:spPr>
+        <p:txBody>
+          <a:bodyPr wrap="square">
+            <a:spAutoFit/>
+          </a:bodyPr>
+          <a:lstStyle/>
+          <a:p>
+            <a:pPr algn="l"/>
+            <a:r>
+              <a:rPr sz="1200" b="1">
+                <a:solidFill>
+                  <a:srgbClr val="1A1A1A"/>
+                </a:solidFill>
+                <a:latin typeface="Microsoft YaHei"/>
+                <a:ea typeface="Microsoft YaHei"/>
+              </a:rPr>
+              <a:t>平台能力关键指标</a:t>
+            </a:r>
+          </a:p>
+        </p:txBody>
+      </p:sp>
+      <p:sp>
+        <p:nvSpPr>
+          <p:cNvPr id="18" name="Rectangle 17"/>
+          <p:cNvSpPr/>
+          <p:nvPr/>
+        </p:nvSpPr>
+        <p:spPr>
+          <a:xfrm>
+            <a:off x="274320" y="4645152"/>
+            <a:ext cx="1874519" cy="868680"/>
+          </a:xfrm>
+          <a:prstGeom prst="rect">
+            <a:avLst/>
+          </a:prstGeom>
+          <a:solidFill>
+            <a:srgbClr val="FFFFFF"/>
+          </a:solidFill>
+          <a:ln w="12700">
+            <a:solidFill>
+              <a:srgbClr val="D0D8DE"/>
+            </a:solidFill>
+          </a:ln>
+        </p:spPr>
+        <p:style>
+          <a:lnRef idx="1">
+            <a:schemeClr val="accent1"/>
+          </a:lnRef>
+          <a:fillRef idx="3">
+            <a:schemeClr val="accent1"/>
+          </a:fillRef>
+          <a:effectRef idx="2">
+            <a:schemeClr val="accent1"/>
+          </a:effectRef>
+          <a:fontRef idx="minor">
+            <a:schemeClr val="lt1"/>
+          </a:fontRef>
+        </p:style>
+        <p:txBody>
+          <a:bodyPr rtlCol="0" anchor="ctr"/>
+          <a:lstStyle/>
+          <a:p>
+            <a:pPr algn="ctr"/>
+          </a:p>
+        </p:txBody>
+      </p:sp>
+      <p:sp>
+        <p:nvSpPr>
+          <p:cNvPr id="19" name="TextBox 18"/>
+          <p:cNvSpPr txBox="1"/>
+          <p:nvPr/>
+        </p:nvSpPr>
+        <p:spPr>
+          <a:xfrm>
+            <a:off x="347472" y="4681728"/>
+            <a:ext cx="1746503" cy="182880"/>
+          </a:xfrm>
+          <a:prstGeom prst="rect">
+            <a:avLst/>
+          </a:prstGeom>
+          <a:noFill/>
+        </p:spPr>
+        <p:txBody>
+          <a:bodyPr wrap="square">
+            <a:spAutoFit/>
+          </a:bodyPr>
+          <a:lstStyle/>
+          <a:p>
+            <a:pPr algn="l"/>
+            <a:r>
+              <a:rPr sz="900" b="0">
+                <a:solidFill>
+                  <a:srgbClr val="6B6B6B"/>
+                </a:solidFill>
+                <a:latin typeface="Microsoft YaHei"/>
+                <a:ea typeface="Microsoft YaHei"/>
+              </a:rPr>
+              <a:t>FlashKV 命中率</a:t>
+            </a:r>
+          </a:p>
+        </p:txBody>
+      </p:sp>
+      <p:sp>
+        <p:nvSpPr>
+          <p:cNvPr id="20" name="TextBox 19"/>
+          <p:cNvSpPr txBox="1"/>
+          <p:nvPr/>
+        </p:nvSpPr>
+        <p:spPr>
+          <a:xfrm>
+            <a:off x="347472" y="4864608"/>
+            <a:ext cx="1746503" cy="237744"/>
+          </a:xfrm>
+          <a:prstGeom prst="rect">
+            <a:avLst/>
+          </a:prstGeom>
+          <a:noFill/>
+        </p:spPr>
+        <p:txBody>
+          <a:bodyPr wrap="square">
+            <a:spAutoFit/>
+          </a:bodyPr>
+          <a:lstStyle/>
+          <a:p>
+            <a:pPr algn="l"/>
+            <a:r>
+              <a:rPr sz="900" b="0">
+                <a:solidFill>
+                  <a:srgbClr val="4A4A4A"/>
+                </a:solidFill>
+                <a:latin typeface="Microsoft YaHei"/>
+                <a:ea typeface="Microsoft YaHei"/>
+              </a:rPr>
+              <a:t>叠加全局 KV</a:t>
+            </a:r>
+          </a:p>
+        </p:txBody>
+      </p:sp>
+      <p:sp>
+        <p:nvSpPr>
+          <p:cNvPr id="21" name="TextBox 20"/>
+          <p:cNvSpPr txBox="1"/>
+          <p:nvPr/>
+        </p:nvSpPr>
+        <p:spPr>
+          <a:xfrm>
+            <a:off x="347472" y="5102352"/>
+            <a:ext cx="1746503" cy="347472"/>
+          </a:xfrm>
+          <a:prstGeom prst="rect">
+            <a:avLst/>
+          </a:prstGeom>
+          <a:noFill/>
+        </p:spPr>
+        <p:txBody>
+          <a:bodyPr wrap="square">
+            <a:spAutoFit/>
+          </a:bodyPr>
+          <a:lstStyle/>
+          <a:p>
+            <a:pPr algn="l"/>
+            <a:r>
+              <a:rPr sz="1200" b="1">
+                <a:solidFill>
+                  <a:srgbClr val="8B1A2B"/>
+                </a:solidFill>
+                <a:latin typeface="Microsoft YaHei"/>
+                <a:ea typeface="Microsoft YaHei"/>
+              </a:rPr>
+              <a:t>78.62%→94.32%</a:t>
+            </a:r>
+          </a:p>
+        </p:txBody>
+      </p:sp>
+      <p:sp>
+        <p:nvSpPr>
+          <p:cNvPr id="22" name="Rectangle 21"/>
+          <p:cNvSpPr/>
+          <p:nvPr/>
+        </p:nvSpPr>
+        <p:spPr>
+          <a:xfrm>
+            <a:off x="2240279" y="4645152"/>
+            <a:ext cx="1874519" cy="868680"/>
+          </a:xfrm>
+          <a:prstGeom prst="rect">
+            <a:avLst/>
+          </a:prstGeom>
+          <a:solidFill>
+            <a:srgbClr val="FFFFFF"/>
+          </a:solidFill>
+          <a:ln w="12700">
+            <a:solidFill>
+              <a:srgbClr val="D0D8DE"/>
+            </a:solidFill>
+          </a:ln>
+        </p:spPr>
+        <p:style>
+          <a:lnRef idx="1">
+            <a:schemeClr val="accent1"/>
+          </a:lnRef>
+          <a:fillRef idx="3">
+            <a:schemeClr val="accent1"/>
+          </a:fillRef>
+          <a:effectRef idx="2">
+            <a:schemeClr val="accent1"/>
+          </a:effectRef>
+          <a:fontRef idx="minor">
+            <a:schemeClr val="lt1"/>
+          </a:fontRef>
+        </p:style>
+        <p:txBody>
+          <a:bodyPr rtlCol="0" anchor="ctr"/>
+          <a:lstStyle/>
+          <a:p>
+            <a:pPr algn="ctr"/>
+          </a:p>
+        </p:txBody>
+      </p:sp>
+      <p:sp>
+        <p:nvSpPr>
+          <p:cNvPr id="23" name="TextBox 22"/>
+          <p:cNvSpPr txBox="1"/>
+          <p:nvPr/>
+        </p:nvSpPr>
+        <p:spPr>
+          <a:xfrm>
+            <a:off x="2313431" y="4681728"/>
+            <a:ext cx="1746503" cy="182880"/>
+          </a:xfrm>
+          <a:prstGeom prst="rect">
+            <a:avLst/>
+          </a:prstGeom>
+          <a:noFill/>
+        </p:spPr>
+        <p:txBody>
+          <a:bodyPr wrap="square">
+            <a:spAutoFit/>
+          </a:bodyPr>
+          <a:lstStyle/>
+          <a:p>
+            <a:pPr algn="l"/>
+            <a:r>
+              <a:rPr sz="900" b="0">
+                <a:solidFill>
+                  <a:srgbClr val="6B6B6B"/>
+                </a:solidFill>
+                <a:latin typeface="Microsoft YaHei"/>
+                <a:ea typeface="Microsoft YaHei"/>
+              </a:rPr>
+              <a:t>FlashKV TTFT</a:t>
+            </a:r>
+          </a:p>
+        </p:txBody>
+      </p:sp>
+      <p:sp>
+        <p:nvSpPr>
+          <p:cNvPr id="24" name="TextBox 23"/>
+          <p:cNvSpPr txBox="1"/>
+          <p:nvPr/>
+        </p:nvSpPr>
+        <p:spPr>
+          <a:xfrm>
+            <a:off x="2313431" y="4864608"/>
+            <a:ext cx="1746503" cy="237744"/>
+          </a:xfrm>
+          <a:prstGeom prst="rect">
+            <a:avLst/>
+          </a:prstGeom>
+          <a:noFill/>
+        </p:spPr>
+        <p:txBody>
+          <a:bodyPr wrap="square">
+            <a:spAutoFit/>
+          </a:bodyPr>
+          <a:lstStyle/>
+          <a:p>
+            <a:pPr algn="l"/>
+            <a:r>
+              <a:rPr sz="900" b="0">
+                <a:solidFill>
+                  <a:srgbClr val="4A4A4A"/>
+                </a:solidFill>
+                <a:latin typeface="Microsoft YaHei"/>
+                <a:ea typeface="Microsoft YaHei"/>
+              </a:rPr>
+              <a:t>相对前一阶段</a:t>
+            </a:r>
+          </a:p>
+        </p:txBody>
+      </p:sp>
+      <p:sp>
+        <p:nvSpPr>
+          <p:cNvPr id="25" name="TextBox 24"/>
+          <p:cNvSpPr txBox="1"/>
+          <p:nvPr/>
+        </p:nvSpPr>
+        <p:spPr>
+          <a:xfrm>
+            <a:off x="2313431" y="5102352"/>
+            <a:ext cx="1746503" cy="347472"/>
+          </a:xfrm>
+          <a:prstGeom prst="rect">
+            <a:avLst/>
+          </a:prstGeom>
+          <a:noFill/>
+        </p:spPr>
+        <p:txBody>
+          <a:bodyPr wrap="square">
+            <a:spAutoFit/>
+          </a:bodyPr>
+          <a:lstStyle/>
+          <a:p>
+            <a:pPr algn="l"/>
+            <a:r>
+              <a:rPr sz="1200" b="1">
+                <a:solidFill>
+                  <a:srgbClr val="8B1A2B"/>
+                </a:solidFill>
+                <a:latin typeface="Microsoft YaHei"/>
+                <a:ea typeface="Microsoft YaHei"/>
+              </a:rPr>
+              <a:t>-25%</a:t>
+            </a:r>
+          </a:p>
+        </p:txBody>
+      </p:sp>
+      <p:sp>
+        <p:nvSpPr>
+          <p:cNvPr id="26" name="Rectangle 25"/>
+          <p:cNvSpPr/>
+          <p:nvPr/>
+        </p:nvSpPr>
+        <p:spPr>
+          <a:xfrm>
+            <a:off x="4206238" y="4645152"/>
+            <a:ext cx="1874519" cy="868680"/>
+          </a:xfrm>
+          <a:prstGeom prst="rect">
+            <a:avLst/>
+          </a:prstGeom>
+          <a:solidFill>
+            <a:srgbClr val="FFFFFF"/>
+          </a:solidFill>
+          <a:ln w="12700">
+            <a:solidFill>
+              <a:srgbClr val="D0D8DE"/>
+            </a:solidFill>
+          </a:ln>
+        </p:spPr>
+        <p:style>
+          <a:lnRef idx="1">
+            <a:schemeClr val="accent1"/>
+          </a:lnRef>
+          <a:fillRef idx="3">
+            <a:schemeClr val="accent1"/>
+          </a:fillRef>
+          <a:effectRef idx="2">
+            <a:schemeClr val="accent1"/>
+          </a:effectRef>
+          <a:fontRef idx="minor">
+            <a:schemeClr val="lt1"/>
+          </a:fontRef>
+        </p:style>
+        <p:txBody>
+          <a:bodyPr rtlCol="0" anchor="ctr"/>
+          <a:lstStyle/>
+          <a:p>
+            <a:pPr algn="ctr"/>
+          </a:p>
+        </p:txBody>
+      </p:sp>
+      <p:sp>
+        <p:nvSpPr>
+          <p:cNvPr id="27" name="TextBox 26"/>
+          <p:cNvSpPr txBox="1"/>
+          <p:nvPr/>
+        </p:nvSpPr>
+        <p:spPr>
+          <a:xfrm>
+            <a:off x="4279390" y="4681728"/>
+            <a:ext cx="1746503" cy="182880"/>
+          </a:xfrm>
+          <a:prstGeom prst="rect">
+            <a:avLst/>
+          </a:prstGeom>
+          <a:noFill/>
+        </p:spPr>
+        <p:txBody>
+          <a:bodyPr wrap="square">
+            <a:spAutoFit/>
+          </a:bodyPr>
+          <a:lstStyle/>
+          <a:p>
+            <a:pPr algn="l"/>
+            <a:r>
+              <a:rPr sz="900" b="0">
+                <a:solidFill>
+                  <a:srgbClr val="6B6B6B"/>
+                </a:solidFill>
+                <a:latin typeface="Microsoft YaHei"/>
+                <a:ea typeface="Microsoft YaHei"/>
+              </a:rPr>
+              <a:t>FlashKV TPS</a:t>
+            </a:r>
+          </a:p>
+        </p:txBody>
+      </p:sp>
+      <p:sp>
+        <p:nvSpPr>
+          <p:cNvPr id="28" name="TextBox 27"/>
+          <p:cNvSpPr txBox="1"/>
+          <p:nvPr/>
+        </p:nvSpPr>
+        <p:spPr>
+          <a:xfrm>
+            <a:off x="4279390" y="4864608"/>
+            <a:ext cx="1746503" cy="237744"/>
+          </a:xfrm>
+          <a:prstGeom prst="rect">
+            <a:avLst/>
+          </a:prstGeom>
+          <a:noFill/>
+        </p:spPr>
+        <p:txBody>
+          <a:bodyPr wrap="square">
+            <a:spAutoFit/>
+          </a:bodyPr>
+          <a:lstStyle/>
+          <a:p>
+            <a:pPr algn="l"/>
+            <a:r>
+              <a:rPr sz="900" b="0">
+                <a:solidFill>
+                  <a:srgbClr val="4A4A4A"/>
+                </a:solidFill>
+                <a:latin typeface="Microsoft YaHei"/>
+                <a:ea typeface="Microsoft YaHei"/>
+              </a:rPr>
+              <a:t>相对前一阶段</a:t>
+            </a:r>
+          </a:p>
+        </p:txBody>
+      </p:sp>
+      <p:sp>
+        <p:nvSpPr>
+          <p:cNvPr id="29" name="TextBox 28"/>
+          <p:cNvSpPr txBox="1"/>
+          <p:nvPr/>
+        </p:nvSpPr>
+        <p:spPr>
+          <a:xfrm>
+            <a:off x="4279390" y="5102352"/>
+            <a:ext cx="1746503" cy="347472"/>
+          </a:xfrm>
+          <a:prstGeom prst="rect">
+            <a:avLst/>
+          </a:prstGeom>
+          <a:noFill/>
+        </p:spPr>
+        <p:txBody>
+          <a:bodyPr wrap="square">
+            <a:spAutoFit/>
+          </a:bodyPr>
+          <a:lstStyle/>
+          <a:p>
+            <a:pPr algn="l"/>
+            <a:r>
+              <a:rPr sz="1200" b="1">
+                <a:solidFill>
+                  <a:srgbClr val="8B1A2B"/>
+                </a:solidFill>
+                <a:latin typeface="Microsoft YaHei"/>
+                <a:ea typeface="Microsoft YaHei"/>
+              </a:rPr>
+              <a:t>+40%</a:t>
+            </a:r>
+          </a:p>
+        </p:txBody>
+      </p:sp>
+      <p:sp>
+        <p:nvSpPr>
+          <p:cNvPr id="30" name="Rectangle 29"/>
+          <p:cNvSpPr/>
+          <p:nvPr/>
+        </p:nvSpPr>
+        <p:spPr>
+          <a:xfrm>
+            <a:off x="6172197" y="4645152"/>
+            <a:ext cx="1874519" cy="868680"/>
+          </a:xfrm>
+          <a:prstGeom prst="rect">
+            <a:avLst/>
+          </a:prstGeom>
+          <a:solidFill>
+            <a:srgbClr val="FFFFFF"/>
+          </a:solidFill>
+          <a:ln w="12700">
+            <a:solidFill>
+              <a:srgbClr val="D0D8DE"/>
+            </a:solidFill>
+          </a:ln>
+        </p:spPr>
+        <p:style>
+          <a:lnRef idx="1">
+            <a:schemeClr val="accent1"/>
+          </a:lnRef>
+          <a:fillRef idx="3">
+            <a:schemeClr val="accent1"/>
+          </a:fillRef>
+          <a:effectRef idx="2">
+            <a:schemeClr val="accent1"/>
+          </a:effectRef>
+          <a:fontRef idx="minor">
+            <a:schemeClr val="lt1"/>
+          </a:fontRef>
+        </p:style>
+        <p:txBody>
+          <a:bodyPr rtlCol="0" anchor="ctr"/>
+          <a:lstStyle/>
+          <a:p>
+            <a:pPr algn="ctr"/>
+          </a:p>
+        </p:txBody>
+      </p:sp>
+      <p:sp>
+        <p:nvSpPr>
+          <p:cNvPr id="31" name="TextBox 30"/>
+          <p:cNvSpPr txBox="1"/>
+          <p:nvPr/>
+        </p:nvSpPr>
+        <p:spPr>
+          <a:xfrm>
+            <a:off x="6245349" y="4681728"/>
+            <a:ext cx="1746503" cy="182880"/>
+          </a:xfrm>
+          <a:prstGeom prst="rect">
+            <a:avLst/>
+          </a:prstGeom>
+          <a:noFill/>
+        </p:spPr>
+        <p:txBody>
+          <a:bodyPr wrap="square">
+            <a:spAutoFit/>
+          </a:bodyPr>
+          <a:lstStyle/>
+          <a:p>
+            <a:pPr algn="l"/>
+            <a:r>
+              <a:rPr sz="900" b="0">
+                <a:solidFill>
+                  <a:srgbClr val="6B6B6B"/>
+                </a:solidFill>
+                <a:latin typeface="Microsoft YaHei"/>
+                <a:ea typeface="Microsoft YaHei"/>
+              </a:rPr>
+              <a:t>模型加载</a:t>
+            </a:r>
+          </a:p>
+        </p:txBody>
+      </p:sp>
+      <p:sp>
+        <p:nvSpPr>
+          <p:cNvPr id="32" name="TextBox 31"/>
+          <p:cNvSpPr txBox="1"/>
+          <p:nvPr/>
+        </p:nvSpPr>
+        <p:spPr>
+          <a:xfrm>
+            <a:off x="6245349" y="4864608"/>
+            <a:ext cx="1746503" cy="237744"/>
+          </a:xfrm>
+          <a:prstGeom prst="rect">
+            <a:avLst/>
+          </a:prstGeom>
+          <a:noFill/>
+        </p:spPr>
+        <p:txBody>
+          <a:bodyPr wrap="square">
+            <a:spAutoFit/>
+          </a:bodyPr>
+          <a:lstStyle/>
+          <a:p>
+            <a:pPr algn="l"/>
+            <a:r>
+              <a:rPr sz="900" b="0">
+                <a:solidFill>
+                  <a:srgbClr val="4A4A4A"/>
+                </a:solidFill>
+                <a:latin typeface="Microsoft YaHei"/>
+                <a:ea typeface="Microsoft YaHei"/>
+              </a:rPr>
+              <a:t>远端直读→分发加速</a:t>
+            </a:r>
+          </a:p>
+        </p:txBody>
+      </p:sp>
+      <p:sp>
+        <p:nvSpPr>
+          <p:cNvPr id="33" name="TextBox 32"/>
+          <p:cNvSpPr txBox="1"/>
+          <p:nvPr/>
+        </p:nvSpPr>
+        <p:spPr>
+          <a:xfrm>
+            <a:off x="6245349" y="5102352"/>
+            <a:ext cx="1746503" cy="347472"/>
+          </a:xfrm>
+          <a:prstGeom prst="rect">
+            <a:avLst/>
+          </a:prstGeom>
+          <a:noFill/>
+        </p:spPr>
+        <p:txBody>
+          <a:bodyPr wrap="square">
+            <a:spAutoFit/>
+          </a:bodyPr>
+          <a:lstStyle/>
+          <a:p>
+            <a:pPr algn="l"/>
+            <a:r>
+              <a:rPr sz="1200" b="1">
+                <a:solidFill>
+                  <a:srgbClr val="8B1A2B"/>
+                </a:solidFill>
+                <a:latin typeface="Microsoft YaHei"/>
+                <a:ea typeface="Microsoft YaHei"/>
+              </a:rPr>
+              <a:t>数十分钟→秒级</a:t>
+            </a:r>
+          </a:p>
+        </p:txBody>
+      </p:sp>
+      <p:sp>
+        <p:nvSpPr>
+          <p:cNvPr id="34" name="Rectangle 33"/>
+          <p:cNvSpPr/>
+          <p:nvPr/>
+        </p:nvSpPr>
+        <p:spPr>
+          <a:xfrm>
+            <a:off x="8138156" y="4645152"/>
+            <a:ext cx="1874519" cy="868680"/>
+          </a:xfrm>
+          <a:prstGeom prst="rect">
+            <a:avLst/>
+          </a:prstGeom>
+          <a:solidFill>
+            <a:srgbClr val="FFFFFF"/>
+          </a:solidFill>
+          <a:ln w="12700">
+            <a:solidFill>
+              <a:srgbClr val="D0D8DE"/>
+            </a:solidFill>
+          </a:ln>
+        </p:spPr>
+        <p:style>
+          <a:lnRef idx="1">
+            <a:schemeClr val="accent1"/>
+          </a:lnRef>
+          <a:fillRef idx="3">
+            <a:schemeClr val="accent1"/>
+          </a:fillRef>
+          <a:effectRef idx="2">
+            <a:schemeClr val="accent1"/>
+          </a:effectRef>
+          <a:fontRef idx="minor">
+            <a:schemeClr val="lt1"/>
+          </a:fontRef>
+        </p:style>
+        <p:txBody>
+          <a:bodyPr rtlCol="0" anchor="ctr"/>
+          <a:lstStyle/>
+          <a:p>
+            <a:pPr algn="ctr"/>
+          </a:p>
+        </p:txBody>
+      </p:sp>
+      <p:sp>
+        <p:nvSpPr>
+          <p:cNvPr id="35" name="TextBox 34"/>
+          <p:cNvSpPr txBox="1"/>
+          <p:nvPr/>
+        </p:nvSpPr>
+        <p:spPr>
+          <a:xfrm>
+            <a:off x="8211308" y="4681728"/>
+            <a:ext cx="1746503" cy="182880"/>
+          </a:xfrm>
+          <a:prstGeom prst="rect">
+            <a:avLst/>
+          </a:prstGeom>
+          <a:noFill/>
+        </p:spPr>
+        <p:txBody>
+          <a:bodyPr wrap="square">
+            <a:spAutoFit/>
+          </a:bodyPr>
+          <a:lstStyle/>
+          <a:p>
+            <a:pPr algn="l"/>
+            <a:r>
+              <a:rPr sz="900" b="0">
+                <a:solidFill>
+                  <a:srgbClr val="6B6B6B"/>
+                </a:solidFill>
+                <a:latin typeface="Microsoft YaHei"/>
+                <a:ea typeface="Microsoft YaHei"/>
+              </a:rPr>
+              <a:t>批量规格</a:t>
+            </a:r>
+          </a:p>
+        </p:txBody>
+      </p:sp>
+      <p:sp>
+        <p:nvSpPr>
+          <p:cNvPr id="36" name="TextBox 35"/>
+          <p:cNvSpPr txBox="1"/>
+          <p:nvPr/>
+        </p:nvSpPr>
+        <p:spPr>
+          <a:xfrm>
+            <a:off x="8211308" y="4864608"/>
+            <a:ext cx="1746503" cy="237744"/>
+          </a:xfrm>
+          <a:prstGeom prst="rect">
+            <a:avLst/>
+          </a:prstGeom>
+          <a:noFill/>
+        </p:spPr>
+        <p:txBody>
+          <a:bodyPr wrap="square">
+            <a:spAutoFit/>
+          </a:bodyPr>
+          <a:lstStyle/>
+          <a:p>
+            <a:pPr algn="l"/>
+            <a:r>
+              <a:rPr sz="900" b="0">
+                <a:solidFill>
+                  <a:srgbClr val="4A4A4A"/>
+                </a:solidFill>
+                <a:latin typeface="Microsoft YaHei"/>
+                <a:ea typeface="Microsoft YaHei"/>
+              </a:rPr>
+              <a:t>单任务上限</a:t>
+            </a:r>
+          </a:p>
+        </p:txBody>
+      </p:sp>
+      <p:sp>
+        <p:nvSpPr>
+          <p:cNvPr id="37" name="TextBox 36"/>
+          <p:cNvSpPr txBox="1"/>
+          <p:nvPr/>
+        </p:nvSpPr>
+        <p:spPr>
+          <a:xfrm>
+            <a:off x="8211308" y="5102352"/>
+            <a:ext cx="1746503" cy="347472"/>
+          </a:xfrm>
+          <a:prstGeom prst="rect">
+            <a:avLst/>
+          </a:prstGeom>
+          <a:noFill/>
+        </p:spPr>
+        <p:txBody>
+          <a:bodyPr wrap="square">
+            <a:spAutoFit/>
+          </a:bodyPr>
+          <a:lstStyle/>
+          <a:p>
+            <a:pPr algn="l"/>
+            <a:r>
+              <a:rPr sz="1200" b="1">
+                <a:solidFill>
+                  <a:srgbClr val="8B1A2B"/>
+                </a:solidFill>
+                <a:latin typeface="Microsoft YaHei"/>
+                <a:ea typeface="Microsoft YaHei"/>
+              </a:rPr>
+              <a:t>5万行 / 200MB</a:t>
+            </a:r>
+          </a:p>
+        </p:txBody>
+      </p:sp>
+      <p:sp>
+        <p:nvSpPr>
+          <p:cNvPr id="38" name="Rectangle 37"/>
+          <p:cNvSpPr/>
+          <p:nvPr/>
+        </p:nvSpPr>
+        <p:spPr>
+          <a:xfrm>
+            <a:off x="10104115" y="4645152"/>
+            <a:ext cx="1874519" cy="868680"/>
+          </a:xfrm>
+          <a:prstGeom prst="rect">
+            <a:avLst/>
+          </a:prstGeom>
+          <a:solidFill>
+            <a:srgbClr val="FFFFFF"/>
+          </a:solidFill>
+          <a:ln w="12700">
+            <a:solidFill>
+              <a:srgbClr val="D0D8DE"/>
+            </a:solidFill>
+          </a:ln>
+        </p:spPr>
+        <p:style>
+          <a:lnRef idx="1">
+            <a:schemeClr val="accent1"/>
+          </a:lnRef>
+          <a:fillRef idx="3">
+            <a:schemeClr val="accent1"/>
+          </a:fillRef>
+          <a:effectRef idx="2">
+            <a:schemeClr val="accent1"/>
+          </a:effectRef>
+          <a:fontRef idx="minor">
+            <a:schemeClr val="lt1"/>
+          </a:fontRef>
+        </p:style>
+        <p:txBody>
+          <a:bodyPr rtlCol="0" anchor="ctr"/>
+          <a:lstStyle/>
+          <a:p>
+            <a:pPr algn="ctr"/>
+          </a:p>
+        </p:txBody>
+      </p:sp>
+      <p:sp>
+        <p:nvSpPr>
+          <p:cNvPr id="39" name="TextBox 38"/>
+          <p:cNvSpPr txBox="1"/>
+          <p:nvPr/>
+        </p:nvSpPr>
+        <p:spPr>
+          <a:xfrm>
+            <a:off x="10177267" y="4681728"/>
+            <a:ext cx="1746503" cy="182880"/>
+          </a:xfrm>
+          <a:prstGeom prst="rect">
+            <a:avLst/>
+          </a:prstGeom>
+          <a:noFill/>
+        </p:spPr>
+        <p:txBody>
+          <a:bodyPr wrap="square">
+            <a:spAutoFit/>
+          </a:bodyPr>
+          <a:lstStyle/>
+          <a:p>
+            <a:pPr algn="l"/>
+            <a:r>
+              <a:rPr sz="900" b="0">
+                <a:solidFill>
+                  <a:srgbClr val="6B6B6B"/>
+                </a:solidFill>
+                <a:latin typeface="Microsoft YaHei"/>
+                <a:ea typeface="Microsoft YaHei"/>
+              </a:rPr>
+              <a:t>安全形态</a:t>
+            </a:r>
+          </a:p>
+        </p:txBody>
+      </p:sp>
+      <p:sp>
+        <p:nvSpPr>
+          <p:cNvPr id="40" name="TextBox 39"/>
+          <p:cNvSpPr txBox="1"/>
+          <p:nvPr/>
+        </p:nvSpPr>
+        <p:spPr>
+          <a:xfrm>
+            <a:off x="10177267" y="4864608"/>
+            <a:ext cx="1746503" cy="237744"/>
+          </a:xfrm>
+          <a:prstGeom prst="rect">
+            <a:avLst/>
+          </a:prstGeom>
+          <a:noFill/>
+        </p:spPr>
+        <p:txBody>
+          <a:bodyPr wrap="square">
+            <a:spAutoFit/>
+          </a:bodyPr>
+          <a:lstStyle/>
+          <a:p>
+            <a:pPr algn="l"/>
+            <a:r>
+              <a:rPr sz="900" b="0">
+                <a:solidFill>
+                  <a:srgbClr val="4A4A4A"/>
+                </a:solidFill>
+                <a:latin typeface="Microsoft YaHei"/>
+                <a:ea typeface="Microsoft YaHei"/>
+              </a:rPr>
+              <a:t>承诺式→可验证</a:t>
+            </a:r>
+          </a:p>
+        </p:txBody>
+      </p:sp>
+      <p:sp>
+        <p:nvSpPr>
+          <p:cNvPr id="41" name="TextBox 40"/>
+          <p:cNvSpPr txBox="1"/>
+          <p:nvPr/>
+        </p:nvSpPr>
+        <p:spPr>
+          <a:xfrm>
+            <a:off x="10177267" y="5102352"/>
+            <a:ext cx="1746503" cy="347472"/>
+          </a:xfrm>
+          <a:prstGeom prst="rect">
+            <a:avLst/>
+          </a:prstGeom>
+          <a:noFill/>
+        </p:spPr>
+        <p:txBody>
+          <a:bodyPr wrap="square">
+            <a:spAutoFit/>
+          </a:bodyPr>
+          <a:lstStyle/>
+          <a:p>
+            <a:pPr algn="l"/>
+            <a:r>
+              <a:rPr sz="1200" b="1">
+                <a:solidFill>
+                  <a:srgbClr val="8B1A2B"/>
+                </a:solidFill>
+                <a:latin typeface="Microsoft YaHei"/>
+                <a:ea typeface="Microsoft YaHei"/>
+              </a:rPr>
+              <a:t>TEE+远程证明</a:t>
+            </a:r>
+          </a:p>
+        </p:txBody>
+      </p:sp>
+      <p:sp>
+        <p:nvSpPr>
+          <p:cNvPr id="42" name="Rectangle 41"/>
+          <p:cNvSpPr/>
+          <p:nvPr/>
+        </p:nvSpPr>
+        <p:spPr>
+          <a:xfrm>
+            <a:off x="0" y="5742432"/>
+            <a:ext cx="12191695" cy="1115568"/>
+          </a:xfrm>
+          <a:prstGeom prst="rect">
+            <a:avLst/>
+          </a:prstGeom>
+          <a:solidFill>
+            <a:srgbClr val="FFFFFF"/>
+          </a:solidFill>
+          <a:ln>
+            <a:noFill/>
+          </a:ln>
+        </p:spPr>
+        <p:style>
+          <a:lnRef idx="1">
+            <a:schemeClr val="accent1"/>
+          </a:lnRef>
+          <a:fillRef idx="3">
+            <a:schemeClr val="accent1"/>
+          </a:fillRef>
+          <a:effectRef idx="2">
+            <a:schemeClr val="accent1"/>
+          </a:effectRef>
+          <a:fontRef idx="minor">
+            <a:schemeClr val="lt1"/>
+          </a:fontRef>
+        </p:style>
+        <p:txBody>
+          <a:bodyPr rtlCol="0" anchor="ctr"/>
+          <a:lstStyle/>
+          <a:p>
+            <a:pPr algn="ctr"/>
+          </a:p>
+        </p:txBody>
+      </p:sp>
+      <p:sp>
+        <p:nvSpPr>
+          <p:cNvPr id="43" name="TextBox 42"/>
+          <p:cNvSpPr txBox="1"/>
+          <p:nvPr/>
+        </p:nvSpPr>
+        <p:spPr>
+          <a:xfrm>
+            <a:off x="320040" y="5797296"/>
+            <a:ext cx="11521440" cy="530352"/>
+          </a:xfrm>
+          <a:prstGeom prst="rect">
+            <a:avLst/>
+          </a:prstGeom>
+          <a:noFill/>
+        </p:spPr>
+        <p:txBody>
+          <a:bodyPr wrap="square">
+            <a:spAutoFit/>
+          </a:bodyPr>
+          <a:lstStyle/>
+          <a:p>
+            <a:pPr algn="l"/>
+            <a:r>
+              <a:rPr sz="1100" b="1">
+                <a:solidFill>
+                  <a:srgbClr val="1A1A1A"/>
+                </a:solidFill>
+                <a:latin typeface="Microsoft YaHei"/>
+                <a:ea typeface="Microsoft YaHei"/>
+              </a:rPr>
+              <a:t>技术启示：用跨 Region 联邦吃尽 Spot 库存；用四维闸门把 Token 经济写进准入路径；用可用性感知灰度与录制回放把发布风险前移；用 FlashKV/CacheFS 消除缩容与加载税；用 TEE+远程证明将模型/Prompt 保护从口头承诺升级为硬件背书的可验证执行。</a:t>
+            </a:r>
+          </a:p>
+        </p:txBody>
+      </p:sp>
+      <p:sp>
+        <p:nvSpPr>
+          <p:cNvPr id="44" name="TextBox 43"/>
+          <p:cNvSpPr txBox="1"/>
+          <p:nvPr/>
+        </p:nvSpPr>
+        <p:spPr>
+          <a:xfrm>
+            <a:off x="320040" y="6291072"/>
+            <a:ext cx="11521440" cy="237744"/>
+          </a:xfrm>
+          <a:prstGeom prst="rect">
+            <a:avLst/>
+          </a:prstGeom>
+          <a:noFill/>
+        </p:spPr>
+        <p:txBody>
+          <a:bodyPr wrap="square">
+            <a:spAutoFit/>
+          </a:bodyPr>
+          <a:lstStyle/>
+          <a:p>
+            <a:pPr algn="l"/>
+            <a:r>
+              <a:rPr sz="900" b="0">
+                <a:solidFill>
+                  <a:srgbClr val="6B6B6B"/>
+                </a:solidFill>
+                <a:latin typeface="Microsoft YaHei"/>
+                <a:ea typeface="Microsoft YaHei"/>
+              </a:rPr>
+              <a:t>来源：云栖大会｜阿里云 PAI《Agentic Inference：推理系统的全链路优化》· 覆盖第6–15章</a:t>
             </a:r>
           </a:p>
         </p:txBody>

</xml_diff>

<commit_message>
Rewrite Agentic Inference judgments and insights for briefing
Recast page-1/2 一句话判断 and 技术启示 as distilled technical viewpoints for leaders and cloud architects, aligned with the ACK×小红书 insight style.

Co-authored-by: Annie <Annie-Summer@users.noreply.github.com>
</commit_message>
<xml_diff>
--- a/yunqi-2026-pai-forum/docs/洞察一页-05-Agentic Inference：从议题看有状态推理全链路优化.pptx
+++ b/yunqi-2026-pai-forum/docs/洞察一页-05-Agentic Inference：从议题看有状态推理全链路优化.pptx
@@ -3323,7 +3323,7 @@
                 <a:latin typeface="Microsoft YaHei"/>
                 <a:ea typeface="Microsoft YaHei"/>
               </a:rPr>
-              <a:t>一句话判断：Agentic Inference 将推理从无状态 QPS 服务，重构为「长上下文 + KV 前缀命中 + Token 级流控 + 会话亲和」系统问题；PAI 以流量调度 / 引擎执行 / 全局缓存三层协同，并用 Session/Cache-Aware 调度与智能选模同时抬 TTFT/TPS、压综合成本。</a:t>
+              <a:t>一句话判断：Agent 多轮长上下文下，无状态 QPS 调度保不住前缀命中与 Token 成本；PAI 以 Session/Cache-Aware 调度叠加难度分流选模，把 KV 命中率做到约 79%、TTFT 降约 33%、TPS 约翻倍，并用 Auto 选模在质量提升同时把成本指数压到约 35%。</a:t>
             </a:r>
           </a:p>
         </p:txBody>
@@ -3444,7 +3444,7 @@
                 <a:latin typeface="Microsoft YaHei"/>
                 <a:ea typeface="Microsoft YaHei"/>
               </a:rPr>
-              <a:t>技术启示：调度目标函数切到 Session×KV命中×Token成本</a:t>
+              <a:t>技术启示：调度 SLO 要从实例 QPS，切到 Session 命中与 Token 成本</a:t>
             </a:r>
           </a:p>
           <a:p>
@@ -3633,7 +3633,7 @@
                 <a:latin typeface="Microsoft YaHei"/>
                 <a:ea typeface="Microsoft YaHei"/>
               </a:rPr>
-              <a:t>技术启示：控制面五层能力与执行/缓存面必须同代交付</a:t>
+              <a:t>技术启示：调度、执行、全局 KV 必须同代交付，单点引擎优化不够</a:t>
             </a:r>
           </a:p>
           <a:p>
@@ -3822,7 +3822,7 @@
                 <a:latin typeface="Microsoft YaHei"/>
                 <a:ea typeface="Microsoft YaHei"/>
               </a:rPr>
-              <a:t>技术启示：策略级联提命中，难度分流做质量-成本帕累托</a:t>
+              <a:t>技术启示：先保会话/前缀命中，再用难度分流固化质量-成本边界</a:t>
             </a:r>
           </a:p>
           <a:p>
@@ -3890,7 +3890,7 @@
                 <a:latin typeface="Microsoft YaHei"/>
                 <a:ea typeface="Microsoft YaHei"/>
               </a:rPr>
-              <a:t>• Auto 选模 L1/L2/L3：客户端写 auto，无实例自动切候选</a:t>
+              <a:t>• Auto 选模 L1/L2/L3：客户端写 auto，网关实例自动切候选</a:t>
             </a:r>
           </a:p>
         </p:txBody>
@@ -3903,7 +3903,7 @@
         </p:nvSpPr>
         <p:spPr>
           <a:xfrm>
-            <a:off x="274320" y="4462272"/>
+            <a:off x="274320" y="4370832"/>
             <a:ext cx="9144000" cy="219456"/>
           </a:xfrm>
           <a:prstGeom prst="rect">
@@ -3939,7 +3939,7 @@
         </p:nvSpPr>
         <p:spPr>
           <a:xfrm>
-            <a:off x="274320" y="4700016"/>
+            <a:off x="274320" y="4608576"/>
             <a:ext cx="1874519" cy="868680"/>
           </a:xfrm>
           <a:prstGeom prst="rect">
@@ -3984,7 +3984,7 @@
         </p:nvSpPr>
         <p:spPr>
           <a:xfrm>
-            <a:off x="347472" y="4736592"/>
+            <a:off x="347472" y="4645152"/>
             <a:ext cx="1746503" cy="182880"/>
           </a:xfrm>
           <a:prstGeom prst="rect">
@@ -4020,7 +4020,7 @@
         </p:nvSpPr>
         <p:spPr>
           <a:xfrm>
-            <a:off x="347472" y="4919472"/>
+            <a:off x="347472" y="4828032"/>
             <a:ext cx="1746503" cy="237744"/>
           </a:xfrm>
           <a:prstGeom prst="rect">
@@ -4056,7 +4056,7 @@
         </p:nvSpPr>
         <p:spPr>
           <a:xfrm>
-            <a:off x="347472" y="5157216"/>
+            <a:off x="347472" y="5065776"/>
             <a:ext cx="1746503" cy="347472"/>
           </a:xfrm>
           <a:prstGeom prst="rect">
@@ -4092,7 +4092,7 @@
         </p:nvSpPr>
         <p:spPr>
           <a:xfrm>
-            <a:off x="2240279" y="4700016"/>
+            <a:off x="2240279" y="4608576"/>
             <a:ext cx="1874519" cy="868680"/>
           </a:xfrm>
           <a:prstGeom prst="rect">
@@ -4137,7 +4137,7 @@
         </p:nvSpPr>
         <p:spPr>
           <a:xfrm>
-            <a:off x="2313431" y="4736592"/>
+            <a:off x="2313431" y="4645152"/>
             <a:ext cx="1746503" cy="182880"/>
           </a:xfrm>
           <a:prstGeom prst="rect">
@@ -4173,7 +4173,7 @@
         </p:nvSpPr>
         <p:spPr>
           <a:xfrm>
-            <a:off x="2313431" y="4919472"/>
+            <a:off x="2313431" y="4828032"/>
             <a:ext cx="1746503" cy="237744"/>
           </a:xfrm>
           <a:prstGeom prst="rect">
@@ -4209,7 +4209,7 @@
         </p:nvSpPr>
         <p:spPr>
           <a:xfrm>
-            <a:off x="2313431" y="5157216"/>
+            <a:off x="2313431" y="5065776"/>
             <a:ext cx="1746503" cy="347472"/>
           </a:xfrm>
           <a:prstGeom prst="rect">
@@ -4245,7 +4245,7 @@
         </p:nvSpPr>
         <p:spPr>
           <a:xfrm>
-            <a:off x="4206238" y="4700016"/>
+            <a:off x="4206238" y="4608576"/>
             <a:ext cx="1874519" cy="868680"/>
           </a:xfrm>
           <a:prstGeom prst="rect">
@@ -4290,7 +4290,7 @@
         </p:nvSpPr>
         <p:spPr>
           <a:xfrm>
-            <a:off x="4279390" y="4736592"/>
+            <a:off x="4279390" y="4645152"/>
             <a:ext cx="1746503" cy="182880"/>
           </a:xfrm>
           <a:prstGeom prst="rect">
@@ -4326,7 +4326,7 @@
         </p:nvSpPr>
         <p:spPr>
           <a:xfrm>
-            <a:off x="4279390" y="4919472"/>
+            <a:off x="4279390" y="4828032"/>
             <a:ext cx="1746503" cy="237744"/>
           </a:xfrm>
           <a:prstGeom prst="rect">
@@ -4362,7 +4362,7 @@
         </p:nvSpPr>
         <p:spPr>
           <a:xfrm>
-            <a:off x="4279390" y="5157216"/>
+            <a:off x="4279390" y="5065776"/>
             <a:ext cx="1746503" cy="347472"/>
           </a:xfrm>
           <a:prstGeom prst="rect">
@@ -4398,7 +4398,7 @@
         </p:nvSpPr>
         <p:spPr>
           <a:xfrm>
-            <a:off x="6172197" y="4700016"/>
+            <a:off x="6172197" y="4608576"/>
             <a:ext cx="1874519" cy="868680"/>
           </a:xfrm>
           <a:prstGeom prst="rect">
@@ -4443,7 +4443,7 @@
         </p:nvSpPr>
         <p:spPr>
           <a:xfrm>
-            <a:off x="6245349" y="4736592"/>
+            <a:off x="6245349" y="4645152"/>
             <a:ext cx="1746503" cy="182880"/>
           </a:xfrm>
           <a:prstGeom prst="rect">
@@ -4479,7 +4479,7 @@
         </p:nvSpPr>
         <p:spPr>
           <a:xfrm>
-            <a:off x="6245349" y="4919472"/>
+            <a:off x="6245349" y="4828032"/>
             <a:ext cx="1746503" cy="237744"/>
           </a:xfrm>
           <a:prstGeom prst="rect">
@@ -4515,7 +4515,7 @@
         </p:nvSpPr>
         <p:spPr>
           <a:xfrm>
-            <a:off x="6245349" y="5157216"/>
+            <a:off x="6245349" y="5065776"/>
             <a:ext cx="1746503" cy="347472"/>
           </a:xfrm>
           <a:prstGeom prst="rect">
@@ -4551,7 +4551,7 @@
         </p:nvSpPr>
         <p:spPr>
           <a:xfrm>
-            <a:off x="8138156" y="4700016"/>
+            <a:off x="8138156" y="4608576"/>
             <a:ext cx="1874519" cy="868680"/>
           </a:xfrm>
           <a:prstGeom prst="rect">
@@ -4596,7 +4596,7 @@
         </p:nvSpPr>
         <p:spPr>
           <a:xfrm>
-            <a:off x="8211308" y="4736592"/>
+            <a:off x="8211308" y="4645152"/>
             <a:ext cx="1746503" cy="182880"/>
           </a:xfrm>
           <a:prstGeom prst="rect">
@@ -4632,7 +4632,7 @@
         </p:nvSpPr>
         <p:spPr>
           <a:xfrm>
-            <a:off x="8211308" y="4919472"/>
+            <a:off x="8211308" y="4828032"/>
             <a:ext cx="1746503" cy="237744"/>
           </a:xfrm>
           <a:prstGeom prst="rect">
@@ -4668,7 +4668,7 @@
         </p:nvSpPr>
         <p:spPr>
           <a:xfrm>
-            <a:off x="8211308" y="5157216"/>
+            <a:off x="8211308" y="5065776"/>
             <a:ext cx="1746503" cy="347472"/>
           </a:xfrm>
           <a:prstGeom prst="rect">
@@ -4704,7 +4704,7 @@
         </p:nvSpPr>
         <p:spPr>
           <a:xfrm>
-            <a:off x="10104115" y="4700016"/>
+            <a:off x="10104115" y="4608576"/>
             <a:ext cx="1874519" cy="868680"/>
           </a:xfrm>
           <a:prstGeom prst="rect">
@@ -4749,7 +4749,7 @@
         </p:nvSpPr>
         <p:spPr>
           <a:xfrm>
-            <a:off x="10177267" y="4736592"/>
+            <a:off x="10177267" y="4645152"/>
             <a:ext cx="1746503" cy="182880"/>
           </a:xfrm>
           <a:prstGeom prst="rect">
@@ -4785,7 +4785,7 @@
         </p:nvSpPr>
         <p:spPr>
           <a:xfrm>
-            <a:off x="10177267" y="4919472"/>
+            <a:off x="10177267" y="4828032"/>
             <a:ext cx="1746503" cy="237744"/>
           </a:xfrm>
           <a:prstGeom prst="rect">
@@ -4821,7 +4821,7 @@
         </p:nvSpPr>
         <p:spPr>
           <a:xfrm>
-            <a:off x="10177267" y="5157216"/>
+            <a:off x="10177267" y="5065776"/>
             <a:ext cx="1746503" cy="347472"/>
           </a:xfrm>
           <a:prstGeom prst="rect">
@@ -4857,8 +4857,8 @@
         </p:nvSpPr>
         <p:spPr>
           <a:xfrm>
-            <a:off x="0" y="5779008"/>
-            <a:ext cx="12191695" cy="1078992"/>
+            <a:off x="0" y="5650992"/>
+            <a:ext cx="12191695" cy="1207008"/>
           </a:xfrm>
           <a:prstGeom prst="rect">
             <a:avLst/>
@@ -4900,8 +4900,8 @@
         </p:nvSpPr>
         <p:spPr>
           <a:xfrm>
-            <a:off x="320040" y="5833872"/>
-            <a:ext cx="11521440" cy="502920"/>
+            <a:off x="320040" y="5696712"/>
+            <a:ext cx="11521440" cy="658368"/>
           </a:xfrm>
           <a:prstGeom prst="rect">
             <a:avLst/>
@@ -4923,7 +4923,7 @@
                 <a:latin typeface="Microsoft YaHei"/>
                 <a:ea typeface="Microsoft YaHei"/>
               </a:rPr>
-              <a:t>技术启示：把 Session 亲和、KV 命中率、TPM/Token 配额写入调度 SLO；用「五层路由 + PD/并行感知引擎 + 全局 KV」替代单点算子优化；用难度分流选模固化质量-成本帕累托，让旗舰模型只承接难题流量。</a:t>
+              <a:t>技术启示：Agent 多轮负载下，发布准入与弹性观测不能只看实例 QPS/利用率，还需把 Session 亲和成功率、KV 前缀命中率、TPM/Token 配额一并纳入；否则只在推理引擎（并行策略、batching）上拿到的 TTFT/TPS 收益，会被请求打散后的前缀未命中吞掉。控制面要以 Session→Cache→Least-Token 策略级联择址，并与 PD/并行感知执行面、全局 KV 同代交付；选模侧用难度分流，让旗舰模型只承接难题流量。</a:t>
             </a:r>
           </a:p>
         </p:txBody>
@@ -4936,8 +4936,8 @@
         </p:nvSpPr>
         <p:spPr>
           <a:xfrm>
-            <a:off x="320040" y="6309360"/>
-            <a:ext cx="11521440" cy="237744"/>
+            <a:off x="320040" y="6364224"/>
+            <a:ext cx="11521440" cy="219456"/>
           </a:xfrm>
           <a:prstGeom prst="rect">
             <a:avLst/>
@@ -5216,7 +5216,7 @@
                 <a:latin typeface="Microsoft YaHei"/>
                 <a:ea typeface="Microsoft YaHei"/>
               </a:rPr>
-              <a:t>一句话判断：在调度与选模之上，PAI 补齐跨 Region 库存联邦、Token/Coding 订阅闸门、可用性感知灰度、离线批量错峰、录制回放资产化，以及 FlashKV/CacheFS 与 TEE 可验证安全，形成生产级 Agentic Serving。</a:t>
+              <a:t>一句话判断：有状态调度之上，PAI 把跨 Region 库存联邦、Token 计量闸门、可用性感知灰度与录制回放做成控制面默认能力，再用 FlashKV/CacheFS 把命中率推到约 94%、模型加载压到秒级，并以 TEE 远程证明把安全做成可验证执行。</a:t>
             </a:r>
           </a:p>
         </p:txBody>
@@ -5337,7 +5337,7 @@
                 <a:latin typeface="Microsoft YaHei"/>
                 <a:ea typeface="Microsoft YaHei"/>
               </a:rPr>
-              <a:t>技术启示：库存、计量、发布必须进入控制面默认能力</a:t>
+              <a:t>技术启示：库存、计量、发布必须进入控制面，不能只做引擎侧优化</a:t>
             </a:r>
           </a:p>
           <a:p>
@@ -5526,7 +5526,7 @@
                 <a:latin typeface="Microsoft YaHei"/>
                 <a:ea typeface="Microsoft YaHei"/>
               </a:rPr>
-              <a:t>技术启示：流量资产化 + 全形态 PD 统一接入，降低发布与评测成本</a:t>
+              <a:t>技术启示：真实流量验收 + 全形态 PD 统一接入，才能压住发布风险</a:t>
             </a:r>
           </a:p>
           <a:p>
@@ -5715,7 +5715,7 @@
                 <a:latin typeface="Microsoft YaHei"/>
                 <a:ea typeface="Microsoft YaHei"/>
               </a:rPr>
-              <a:t>技术启示：消除弹性税与冷启动税，并把安全升级为可验证执行</a:t>
+              <a:t>技术启示：缩容后命中与冷启时延，决定弹性是否真能省 GPU</a:t>
             </a:r>
           </a:p>
           <a:p>
@@ -6816,7 +6816,7 @@
                 <a:latin typeface="Microsoft YaHei"/>
                 <a:ea typeface="Microsoft YaHei"/>
               </a:rPr>
-              <a:t>技术启示：用跨 Region 联邦吃尽 Spot 库存；用四维闸门把 Token 经济写进准入路径；用可用性感知灰度与录制回放把发布风险前移；用 FlashKV/CacheFS 消除缩容与加载税；用 TEE+远程证明将模型/Prompt 保护从口头承诺升级为硬件背书的可验证执行。</a:t>
+              <a:t>技术启示：跨 Region 联邦与 Token/Coding 四维闸门要把库存利用率与计量写成准入默认项；灰度需可用性感知并校验 PD 配对完整性，发布前用录制回放做真实流量验收。弹性侧要把活跃 KV 外置到 DRAM/SSD（FlashKV）并把权重分发做到秒级就绪，否则缩容后再扩会重新支付冷启与未命中成本；安全侧以 TEE+远程证明替代口头合规承诺。</a:t>
             </a:r>
           </a:p>
         </p:txBody>

</xml_diff>